<commit_message>
Start of week 4
</commit_message>
<xml_diff>
--- a/Lectures/Day_02/Pipeline.pptx
+++ b/Lectures/Day_02/Pipeline.pptx
@@ -6,6 +6,10 @@
   </p:sldMasterIdLst>
   <p:sldIdLst>
     <p:sldId id="256" r:id="rId2"/>
+    <p:sldId id="257" r:id="rId3"/>
+    <p:sldId id="258" r:id="rId4"/>
+    <p:sldId id="259" r:id="rId5"/>
+    <p:sldId id="260" r:id="rId6"/>
   </p:sldIdLst>
   <p:sldSz cx="12192000" cy="6858000"/>
   <p:notesSz cx="6858000" cy="9144000"/>
@@ -261,7 +265,7 @@
           <a:p>
             <a:fld id="{6B531558-3E01-439E-B6E2-7853B2E97E21}" type="datetimeFigureOut">
               <a:rPr lang="en-CA" smtClean="0"/>
-              <a:t>2026-05-15</a:t>
+              <a:t>2026-05-22</a:t>
             </a:fld>
             <a:endParaRPr lang="en-CA"/>
           </a:p>
@@ -461,7 +465,7 @@
           <a:p>
             <a:fld id="{6B531558-3E01-439E-B6E2-7853B2E97E21}" type="datetimeFigureOut">
               <a:rPr lang="en-CA" smtClean="0"/>
-              <a:t>2026-05-15</a:t>
+              <a:t>2026-05-22</a:t>
             </a:fld>
             <a:endParaRPr lang="en-CA"/>
           </a:p>
@@ -671,7 +675,7 @@
           <a:p>
             <a:fld id="{6B531558-3E01-439E-B6E2-7853B2E97E21}" type="datetimeFigureOut">
               <a:rPr lang="en-CA" smtClean="0"/>
-              <a:t>2026-05-15</a:t>
+              <a:t>2026-05-22</a:t>
             </a:fld>
             <a:endParaRPr lang="en-CA"/>
           </a:p>
@@ -871,7 +875,7 @@
           <a:p>
             <a:fld id="{6B531558-3E01-439E-B6E2-7853B2E97E21}" type="datetimeFigureOut">
               <a:rPr lang="en-CA" smtClean="0"/>
-              <a:t>2026-05-15</a:t>
+              <a:t>2026-05-22</a:t>
             </a:fld>
             <a:endParaRPr lang="en-CA"/>
           </a:p>
@@ -1147,7 +1151,7 @@
           <a:p>
             <a:fld id="{6B531558-3E01-439E-B6E2-7853B2E97E21}" type="datetimeFigureOut">
               <a:rPr lang="en-CA" smtClean="0"/>
-              <a:t>2026-05-15</a:t>
+              <a:t>2026-05-22</a:t>
             </a:fld>
             <a:endParaRPr lang="en-CA"/>
           </a:p>
@@ -1415,7 +1419,7 @@
           <a:p>
             <a:fld id="{6B531558-3E01-439E-B6E2-7853B2E97E21}" type="datetimeFigureOut">
               <a:rPr lang="en-CA" smtClean="0"/>
-              <a:t>2026-05-15</a:t>
+              <a:t>2026-05-22</a:t>
             </a:fld>
             <a:endParaRPr lang="en-CA"/>
           </a:p>
@@ -1830,7 +1834,7 @@
           <a:p>
             <a:fld id="{6B531558-3E01-439E-B6E2-7853B2E97E21}" type="datetimeFigureOut">
               <a:rPr lang="en-CA" smtClean="0"/>
-              <a:t>2026-05-15</a:t>
+              <a:t>2026-05-22</a:t>
             </a:fld>
             <a:endParaRPr lang="en-CA"/>
           </a:p>
@@ -1972,7 +1976,7 @@
           <a:p>
             <a:fld id="{6B531558-3E01-439E-B6E2-7853B2E97E21}" type="datetimeFigureOut">
               <a:rPr lang="en-CA" smtClean="0"/>
-              <a:t>2026-05-15</a:t>
+              <a:t>2026-05-22</a:t>
             </a:fld>
             <a:endParaRPr lang="en-CA"/>
           </a:p>
@@ -2085,7 +2089,7 @@
           <a:p>
             <a:fld id="{6B531558-3E01-439E-B6E2-7853B2E97E21}" type="datetimeFigureOut">
               <a:rPr lang="en-CA" smtClean="0"/>
-              <a:t>2026-05-15</a:t>
+              <a:t>2026-05-22</a:t>
             </a:fld>
             <a:endParaRPr lang="en-CA"/>
           </a:p>
@@ -2398,7 +2402,7 @@
           <a:p>
             <a:fld id="{6B531558-3E01-439E-B6E2-7853B2E97E21}" type="datetimeFigureOut">
               <a:rPr lang="en-CA" smtClean="0"/>
-              <a:t>2026-05-15</a:t>
+              <a:t>2026-05-22</a:t>
             </a:fld>
             <a:endParaRPr lang="en-CA"/>
           </a:p>
@@ -2687,7 +2691,7 @@
           <a:p>
             <a:fld id="{6B531558-3E01-439E-B6E2-7853B2E97E21}" type="datetimeFigureOut">
               <a:rPr lang="en-CA" smtClean="0"/>
-              <a:t>2026-05-15</a:t>
+              <a:t>2026-05-22</a:t>
             </a:fld>
             <a:endParaRPr lang="en-CA"/>
           </a:p>
@@ -2930,7 +2934,7 @@
           <a:p>
             <a:fld id="{6B531558-3E01-439E-B6E2-7853B2E97E21}" type="datetimeFigureOut">
               <a:rPr lang="en-CA" smtClean="0"/>
-              <a:t>2026-05-15</a:t>
+              <a:t>2026-05-22</a:t>
             </a:fld>
             <a:endParaRPr lang="en-CA"/>
           </a:p>
@@ -3460,7 +3464,10 @@
           </a:p>
           <a:p>
             <a:pPr algn="ctr"/>
-            <a:endParaRPr lang="en-CA" dirty="0"/>
+            <a:r>
+              <a:rPr lang="en-CA" dirty="0"/>
+              <a:t> </a:t>
+            </a:r>
           </a:p>
         </p:txBody>
       </p:sp>
@@ -3630,10 +3637,10 @@
       </p:sp>
       <p:sp>
         <p:nvSpPr>
-          <p:cNvPr id="7" name="Rectangle 6">
-            <a:extLst>
-              <a:ext uri="{FF2B5EF4-FFF2-40B4-BE49-F238E27FC236}">
-                <a16:creationId xmlns:a16="http://schemas.microsoft.com/office/drawing/2014/main" id="{A0A7DBA7-1C8E-1277-B21A-295B2BF3A4E4}"/>
+          <p:cNvPr id="8" name="Arrow: Right 7">
+            <a:extLst>
+              <a:ext uri="{FF2B5EF4-FFF2-40B4-BE49-F238E27FC236}">
+                <a16:creationId xmlns:a16="http://schemas.microsoft.com/office/drawing/2014/main" id="{9E9D5935-7A52-C77B-8374-E864BCEE7462}"/>
               </a:ext>
             </a:extLst>
           </p:cNvPr>
@@ -3642,22 +3649,22 @@
         </p:nvSpPr>
         <p:spPr>
           <a:xfrm>
-            <a:off x="7224252" y="1543666"/>
-            <a:ext cx="929146" cy="3962400"/>
-          </a:xfrm>
-          <a:prstGeom prst="rect">
+            <a:off x="4113566" y="2708786"/>
+            <a:ext cx="2408903" cy="1558413"/>
+          </a:xfrm>
+          <a:prstGeom prst="rightArrow">
             <a:avLst/>
           </a:prstGeom>
         </p:spPr>
         <p:style>
-          <a:lnRef idx="3">
-            <a:schemeClr val="lt1"/>
+          <a:lnRef idx="1">
+            <a:schemeClr val="dk1"/>
           </a:lnRef>
-          <a:fillRef idx="1">
-            <a:schemeClr val="accent6"/>
+          <a:fillRef idx="3">
+            <a:schemeClr val="dk1"/>
           </a:fillRef>
-          <a:effectRef idx="1">
-            <a:schemeClr val="accent6"/>
+          <a:effectRef idx="2">
+            <a:schemeClr val="dk1"/>
           </a:effectRef>
           <a:fontRef idx="minor">
             <a:schemeClr val="lt1"/>
@@ -3668,26 +3675,16 @@
           <a:lstStyle/>
           <a:p>
             <a:pPr algn="ctr"/>
-            <a:r>
-              <a:rPr lang="en-CA" dirty="0"/>
-              <a:t>Vertex</a:t>
-            </a:r>
-          </a:p>
-          <a:p>
-            <a:pPr algn="ctr"/>
-            <a:r>
-              <a:rPr lang="en-CA" dirty="0"/>
-              <a:t>buffer</a:t>
-            </a:r>
-          </a:p>
-        </p:txBody>
-      </p:sp>
-      <p:sp>
-        <p:nvSpPr>
-          <p:cNvPr id="8" name="Arrow: Right 7">
-            <a:extLst>
-              <a:ext uri="{FF2B5EF4-FFF2-40B4-BE49-F238E27FC236}">
-                <a16:creationId xmlns:a16="http://schemas.microsoft.com/office/drawing/2014/main" id="{9E9D5935-7A52-C77B-8374-E864BCEE7462}"/>
+            <a:endParaRPr lang="en-CA"/>
+          </a:p>
+        </p:txBody>
+      </p:sp>
+      <p:sp>
+        <p:nvSpPr>
+          <p:cNvPr id="12" name="Arrow: Right 11">
+            <a:extLst>
+              <a:ext uri="{FF2B5EF4-FFF2-40B4-BE49-F238E27FC236}">
+                <a16:creationId xmlns:a16="http://schemas.microsoft.com/office/drawing/2014/main" id="{A94E4D52-A290-E5D3-0494-1F5571B038C3}"/>
               </a:ext>
             </a:extLst>
           </p:cNvPr>
@@ -3696,8 +3693,8 @@
         </p:nvSpPr>
         <p:spPr>
           <a:xfrm>
-            <a:off x="4105155" y="2998839"/>
-            <a:ext cx="2162909" cy="1219200"/>
+            <a:off x="11166229" y="3802805"/>
+            <a:ext cx="2261420" cy="1219200"/>
           </a:xfrm>
           <a:prstGeom prst="rightArrow">
             <a:avLst/>
@@ -3722,16 +3719,19 @@
           <a:lstStyle/>
           <a:p>
             <a:pPr algn="ctr"/>
-            <a:endParaRPr lang="en-CA"/>
-          </a:p>
-        </p:txBody>
-      </p:sp>
-      <p:sp>
-        <p:nvSpPr>
-          <p:cNvPr id="11" name="Rectangle: Rounded Corners 10">
-            <a:extLst>
-              <a:ext uri="{FF2B5EF4-FFF2-40B4-BE49-F238E27FC236}">
-                <a16:creationId xmlns:a16="http://schemas.microsoft.com/office/drawing/2014/main" id="{DD8208FC-83C2-3DB4-987C-E51904197546}"/>
+            <a:r>
+              <a:rPr lang="en-CA" dirty="0"/>
+              <a:t>To the screen (back buffer)</a:t>
+            </a:r>
+          </a:p>
+        </p:txBody>
+      </p:sp>
+      <p:sp>
+        <p:nvSpPr>
+          <p:cNvPr id="13" name="Arrow: Right 12">
+            <a:extLst>
+              <a:ext uri="{FF2B5EF4-FFF2-40B4-BE49-F238E27FC236}">
+                <a16:creationId xmlns:a16="http://schemas.microsoft.com/office/drawing/2014/main" id="{5F240329-D1AC-2AA6-9E5F-9F28FBD8DB21}"/>
               </a:ext>
             </a:extLst>
           </p:cNvPr>
@@ -3740,8 +3740,480 @@
         </p:nvSpPr>
         <p:spPr>
           <a:xfrm>
-            <a:off x="8554065" y="1622323"/>
-            <a:ext cx="2792361" cy="2969343"/>
+            <a:off x="7440657" y="2008418"/>
+            <a:ext cx="1556383" cy="1219200"/>
+          </a:xfrm>
+          <a:prstGeom prst="rightArrow">
+            <a:avLst/>
+          </a:prstGeom>
+        </p:spPr>
+        <p:style>
+          <a:lnRef idx="1">
+            <a:schemeClr val="accent2"/>
+          </a:lnRef>
+          <a:fillRef idx="3">
+            <a:schemeClr val="accent2"/>
+          </a:fillRef>
+          <a:effectRef idx="2">
+            <a:schemeClr val="accent2"/>
+          </a:effectRef>
+          <a:fontRef idx="minor">
+            <a:schemeClr val="lt1"/>
+          </a:fontRef>
+        </p:style>
+        <p:txBody>
+          <a:bodyPr rtlCol="0" anchor="ctr"/>
+          <a:lstStyle/>
+          <a:p>
+            <a:pPr algn="ctr"/>
+            <a:r>
+              <a:rPr lang="en-CA" dirty="0"/>
+              <a:t>VL</a:t>
+            </a:r>
+          </a:p>
+        </p:txBody>
+      </p:sp>
+      <p:sp>
+        <p:nvSpPr>
+          <p:cNvPr id="14" name="Rectangle 13">
+            <a:extLst>
+              <a:ext uri="{FF2B5EF4-FFF2-40B4-BE49-F238E27FC236}">
+                <a16:creationId xmlns:a16="http://schemas.microsoft.com/office/drawing/2014/main" id="{FEF9F6F0-10D3-CC44-912C-80D329FB5F3C}"/>
+              </a:ext>
+            </a:extLst>
+          </p:cNvPr>
+          <p:cNvSpPr/>
+          <p:nvPr/>
+        </p:nvSpPr>
+        <p:spPr>
+          <a:xfrm>
+            <a:off x="-3648291" y="1570002"/>
+            <a:ext cx="1779638" cy="3962400"/>
+          </a:xfrm>
+          <a:prstGeom prst="rect">
+            <a:avLst/>
+          </a:prstGeom>
+        </p:spPr>
+        <p:style>
+          <a:lnRef idx="3">
+            <a:schemeClr val="lt1"/>
+          </a:lnRef>
+          <a:fillRef idx="1">
+            <a:schemeClr val="accent6"/>
+          </a:fillRef>
+          <a:effectRef idx="1">
+            <a:schemeClr val="accent6"/>
+          </a:effectRef>
+          <a:fontRef idx="minor">
+            <a:schemeClr val="lt1"/>
+          </a:fontRef>
+        </p:style>
+        <p:txBody>
+          <a:bodyPr rtlCol="0" anchor="ctr"/>
+          <a:lstStyle/>
+          <a:p>
+            <a:pPr algn="ctr"/>
+            <a:r>
+              <a:rPr lang="en-CA" dirty="0"/>
+              <a:t>File</a:t>
+            </a:r>
+          </a:p>
+        </p:txBody>
+      </p:sp>
+      <p:sp>
+        <p:nvSpPr>
+          <p:cNvPr id="15" name="Arrow: Right 14">
+            <a:extLst>
+              <a:ext uri="{FF2B5EF4-FFF2-40B4-BE49-F238E27FC236}">
+                <a16:creationId xmlns:a16="http://schemas.microsoft.com/office/drawing/2014/main" id="{54854930-83AB-D2BB-035E-DDEA1FA8DE37}"/>
+              </a:ext>
+            </a:extLst>
+          </p:cNvPr>
+          <p:cNvSpPr/>
+          <p:nvPr/>
+        </p:nvSpPr>
+        <p:spPr>
+          <a:xfrm>
+            <a:off x="-2010696" y="2767079"/>
+            <a:ext cx="1499418" cy="1219200"/>
+          </a:xfrm>
+          <a:prstGeom prst="rightArrow">
+            <a:avLst/>
+          </a:prstGeom>
+        </p:spPr>
+        <p:style>
+          <a:lnRef idx="1">
+            <a:schemeClr val="accent2"/>
+          </a:lnRef>
+          <a:fillRef idx="3">
+            <a:schemeClr val="accent2"/>
+          </a:fillRef>
+          <a:effectRef idx="2">
+            <a:schemeClr val="accent2"/>
+          </a:effectRef>
+          <a:fontRef idx="minor">
+            <a:schemeClr val="lt1"/>
+          </a:fontRef>
+        </p:style>
+        <p:txBody>
+          <a:bodyPr rtlCol="0" anchor="ctr"/>
+          <a:lstStyle/>
+          <a:p>
+            <a:pPr algn="ctr"/>
+            <a:endParaRPr lang="en-CA"/>
+          </a:p>
+        </p:txBody>
+      </p:sp>
+      <p:sp>
+        <p:nvSpPr>
+          <p:cNvPr id="2" name="Rectangle 1">
+            <a:extLst>
+              <a:ext uri="{FF2B5EF4-FFF2-40B4-BE49-F238E27FC236}">
+                <a16:creationId xmlns:a16="http://schemas.microsoft.com/office/drawing/2014/main" id="{8ACAC186-645C-EFF0-E5FA-8B3A73966620}"/>
+              </a:ext>
+            </a:extLst>
+          </p:cNvPr>
+          <p:cNvSpPr/>
+          <p:nvPr/>
+        </p:nvSpPr>
+        <p:spPr>
+          <a:xfrm>
+            <a:off x="6590073" y="1570002"/>
+            <a:ext cx="929146" cy="3962400"/>
+          </a:xfrm>
+          <a:prstGeom prst="rect">
+            <a:avLst/>
+          </a:prstGeom>
+        </p:spPr>
+        <p:style>
+          <a:lnRef idx="3">
+            <a:schemeClr val="lt1"/>
+          </a:lnRef>
+          <a:fillRef idx="1">
+            <a:schemeClr val="accent6"/>
+          </a:fillRef>
+          <a:effectRef idx="1">
+            <a:schemeClr val="accent6"/>
+          </a:effectRef>
+          <a:fontRef idx="minor">
+            <a:schemeClr val="lt1"/>
+          </a:fontRef>
+        </p:style>
+        <p:txBody>
+          <a:bodyPr rtlCol="0" anchor="ctr"/>
+          <a:lstStyle/>
+          <a:p>
+            <a:pPr algn="ctr"/>
+            <a:r>
+              <a:rPr lang="en-CA" dirty="0"/>
+              <a:t>Vertex</a:t>
+            </a:r>
+          </a:p>
+          <a:p>
+            <a:pPr algn="ctr"/>
+            <a:r>
+              <a:rPr lang="en-CA" dirty="0"/>
+              <a:t>buffer</a:t>
+            </a:r>
+          </a:p>
+        </p:txBody>
+      </p:sp>
+      <p:grpSp>
+        <p:nvGrpSpPr>
+          <p:cNvPr id="16" name="Group 15">
+            <a:extLst>
+              <a:ext uri="{FF2B5EF4-FFF2-40B4-BE49-F238E27FC236}">
+                <a16:creationId xmlns:a16="http://schemas.microsoft.com/office/drawing/2014/main" id="{15E6BA04-5031-51A3-836E-552D71263B94}"/>
+              </a:ext>
+            </a:extLst>
+          </p:cNvPr>
+          <p:cNvGrpSpPr/>
+          <p:nvPr/>
+        </p:nvGrpSpPr>
+        <p:grpSpPr>
+          <a:xfrm>
+            <a:off x="8997040" y="1703259"/>
+            <a:ext cx="2838046" cy="3451482"/>
+            <a:chOff x="8571075" y="1622323"/>
+            <a:chExt cx="2838046" cy="3451482"/>
+          </a:xfrm>
+        </p:grpSpPr>
+        <p:sp>
+          <p:nvSpPr>
+            <p:cNvPr id="11" name="Rectangle: Rounded Corners 10">
+              <a:extLst>
+                <a:ext uri="{FF2B5EF4-FFF2-40B4-BE49-F238E27FC236}">
+                  <a16:creationId xmlns:a16="http://schemas.microsoft.com/office/drawing/2014/main" id="{DD8208FC-83C2-3DB4-987C-E51904197546}"/>
+                </a:ext>
+              </a:extLst>
+            </p:cNvPr>
+            <p:cNvSpPr/>
+            <p:nvPr/>
+          </p:nvSpPr>
+          <p:spPr>
+            <a:xfrm>
+              <a:off x="8571075" y="1622323"/>
+              <a:ext cx="2838046" cy="3451482"/>
+            </a:xfrm>
+            <a:prstGeom prst="roundRect">
+              <a:avLst/>
+            </a:prstGeom>
+          </p:spPr>
+          <p:style>
+            <a:lnRef idx="0">
+              <a:schemeClr val="accent3"/>
+            </a:lnRef>
+            <a:fillRef idx="3">
+              <a:schemeClr val="accent3"/>
+            </a:fillRef>
+            <a:effectRef idx="3">
+              <a:schemeClr val="accent3"/>
+            </a:effectRef>
+            <a:fontRef idx="minor">
+              <a:schemeClr val="lt1"/>
+            </a:fontRef>
+          </p:style>
+          <p:txBody>
+            <a:bodyPr rtlCol="0" anchor="ctr"/>
+            <a:lstStyle/>
+            <a:p>
+              <a:pPr algn="ctr"/>
+              <a:r>
+                <a:rPr lang="en-CA" dirty="0"/>
+                <a:t>Shader “Program”</a:t>
+              </a:r>
+            </a:p>
+            <a:p>
+              <a:pPr algn="ctr"/>
+              <a:endParaRPr lang="en-CA" dirty="0"/>
+            </a:p>
+            <a:p>
+              <a:pPr algn="ctr"/>
+              <a:endParaRPr lang="en-CA" dirty="0"/>
+            </a:p>
+            <a:p>
+              <a:pPr algn="ctr"/>
+              <a:endParaRPr lang="en-CA" dirty="0"/>
+            </a:p>
+            <a:p>
+              <a:pPr algn="ctr"/>
+              <a:endParaRPr lang="en-CA" dirty="0"/>
+            </a:p>
+            <a:p>
+              <a:pPr algn="ctr"/>
+              <a:endParaRPr lang="en-CA" dirty="0"/>
+            </a:p>
+            <a:p>
+              <a:pPr algn="ctr"/>
+              <a:endParaRPr lang="en-CA" dirty="0"/>
+            </a:p>
+            <a:p>
+              <a:pPr algn="ctr"/>
+              <a:endParaRPr lang="en-CA" dirty="0"/>
+            </a:p>
+            <a:p>
+              <a:pPr algn="ctr"/>
+              <a:endParaRPr lang="en-CA" dirty="0"/>
+            </a:p>
+            <a:p>
+              <a:pPr algn="ctr"/>
+              <a:endParaRPr lang="en-CA" dirty="0"/>
+            </a:p>
+          </p:txBody>
+        </p:sp>
+        <p:sp>
+          <p:nvSpPr>
+            <p:cNvPr id="9" name="Rectangle: Rounded Corners 8">
+              <a:extLst>
+                <a:ext uri="{FF2B5EF4-FFF2-40B4-BE49-F238E27FC236}">
+                  <a16:creationId xmlns:a16="http://schemas.microsoft.com/office/drawing/2014/main" id="{C770166A-DA62-5E5D-EC57-615034048C5E}"/>
+                </a:ext>
+              </a:extLst>
+            </p:cNvPr>
+            <p:cNvSpPr/>
+            <p:nvPr/>
+          </p:nvSpPr>
+          <p:spPr>
+            <a:xfrm>
+              <a:off x="9026013" y="2271253"/>
+              <a:ext cx="1986116" cy="835742"/>
+            </a:xfrm>
+            <a:prstGeom prst="roundRect">
+              <a:avLst/>
+            </a:prstGeom>
+          </p:spPr>
+          <p:style>
+            <a:lnRef idx="3">
+              <a:schemeClr val="lt1"/>
+            </a:lnRef>
+            <a:fillRef idx="1">
+              <a:schemeClr val="accent4"/>
+            </a:fillRef>
+            <a:effectRef idx="1">
+              <a:schemeClr val="accent4"/>
+            </a:effectRef>
+            <a:fontRef idx="minor">
+              <a:schemeClr val="lt1"/>
+            </a:fontRef>
+          </p:style>
+          <p:txBody>
+            <a:bodyPr rtlCol="0" anchor="ctr"/>
+            <a:lstStyle/>
+            <a:p>
+              <a:pPr algn="ctr"/>
+              <a:r>
+                <a:rPr lang="en-CA" dirty="0">
+                  <a:solidFill>
+                    <a:schemeClr val="tx1"/>
+                  </a:solidFill>
+                </a:rPr>
+                <a:t>Vertex</a:t>
+              </a:r>
+            </a:p>
+          </p:txBody>
+        </p:sp>
+        <p:sp>
+          <p:nvSpPr>
+            <p:cNvPr id="10" name="Rectangle: Rounded Corners 9">
+              <a:extLst>
+                <a:ext uri="{FF2B5EF4-FFF2-40B4-BE49-F238E27FC236}">
+                  <a16:creationId xmlns:a16="http://schemas.microsoft.com/office/drawing/2014/main" id="{F55A8CC1-47C2-1E03-2710-00949FBA61EF}"/>
+                </a:ext>
+              </a:extLst>
+            </p:cNvPr>
+            <p:cNvSpPr/>
+            <p:nvPr/>
+          </p:nvSpPr>
+          <p:spPr>
+            <a:xfrm>
+              <a:off x="8997040" y="3994534"/>
+              <a:ext cx="1986116" cy="835742"/>
+            </a:xfrm>
+            <a:prstGeom prst="roundRect">
+              <a:avLst/>
+            </a:prstGeom>
+          </p:spPr>
+          <p:style>
+            <a:lnRef idx="3">
+              <a:schemeClr val="lt1"/>
+            </a:lnRef>
+            <a:fillRef idx="1">
+              <a:schemeClr val="accent4"/>
+            </a:fillRef>
+            <a:effectRef idx="1">
+              <a:schemeClr val="accent4"/>
+            </a:effectRef>
+            <a:fontRef idx="minor">
+              <a:schemeClr val="lt1"/>
+            </a:fontRef>
+          </p:style>
+          <p:txBody>
+            <a:bodyPr rtlCol="0" anchor="ctr"/>
+            <a:lstStyle/>
+            <a:p>
+              <a:pPr algn="ctr"/>
+              <a:r>
+                <a:rPr lang="en-CA" dirty="0">
+                  <a:solidFill>
+                    <a:schemeClr val="tx1"/>
+                  </a:solidFill>
+                </a:rPr>
+                <a:t>Fragment</a:t>
+              </a:r>
+            </a:p>
+          </p:txBody>
+        </p:sp>
+        <p:sp>
+          <p:nvSpPr>
+            <p:cNvPr id="3" name="Arrow: Right 2">
+              <a:extLst>
+                <a:ext uri="{FF2B5EF4-FFF2-40B4-BE49-F238E27FC236}">
+                  <a16:creationId xmlns:a16="http://schemas.microsoft.com/office/drawing/2014/main" id="{6BB7B67E-06A8-47B3-967E-2CC75F9B0BB9}"/>
+                </a:ext>
+              </a:extLst>
+            </p:cNvPr>
+            <p:cNvSpPr/>
+            <p:nvPr/>
+          </p:nvSpPr>
+          <p:spPr>
+            <a:xfrm rot="5400000">
+              <a:off x="9639431" y="2955872"/>
+              <a:ext cx="858125" cy="1219200"/>
+            </a:xfrm>
+            <a:prstGeom prst="rightArrow">
+              <a:avLst/>
+            </a:prstGeom>
+          </p:spPr>
+          <p:style>
+            <a:lnRef idx="1">
+              <a:schemeClr val="accent2"/>
+            </a:lnRef>
+            <a:fillRef idx="3">
+              <a:schemeClr val="accent2"/>
+            </a:fillRef>
+            <a:effectRef idx="2">
+              <a:schemeClr val="accent2"/>
+            </a:effectRef>
+            <a:fontRef idx="minor">
+              <a:schemeClr val="lt1"/>
+            </a:fontRef>
+          </p:style>
+          <p:txBody>
+            <a:bodyPr rtlCol="0" anchor="ctr"/>
+            <a:lstStyle/>
+            <a:p>
+              <a:pPr algn="ctr"/>
+              <a:endParaRPr lang="en-CA" dirty="0"/>
+            </a:p>
+          </p:txBody>
+        </p:sp>
+      </p:grpSp>
+    </p:spTree>
+    <p:extLst>
+      <p:ext uri="{BB962C8B-B14F-4D97-AF65-F5344CB8AC3E}">
+        <p14:creationId xmlns:p14="http://schemas.microsoft.com/office/powerpoint/2010/main" val="800627848"/>
+      </p:ext>
+    </p:extLst>
+  </p:cSld>
+  <p:clrMapOvr>
+    <a:masterClrMapping/>
+  </p:clrMapOvr>
+</p:sld>
+</file>
+
+<file path=ppt/slides/slide2.xml><?xml version="1.0" encoding="utf-8"?>
+<p:sld xmlns:a="http://schemas.openxmlformats.org/drawingml/2006/main" xmlns:r="http://schemas.openxmlformats.org/officeDocument/2006/relationships" xmlns:p="http://schemas.openxmlformats.org/presentationml/2006/main">
+  <p:cSld>
+    <p:spTree>
+      <p:nvGrpSpPr>
+        <p:cNvPr id="1" name=""/>
+        <p:cNvGrpSpPr/>
+        <p:nvPr/>
+      </p:nvGrpSpPr>
+      <p:grpSpPr>
+        <a:xfrm>
+          <a:off x="0" y="0"/>
+          <a:ext cx="0" cy="0"/>
+          <a:chOff x="0" y="0"/>
+          <a:chExt cx="0" cy="0"/>
+        </a:xfrm>
+      </p:grpSpPr>
+      <p:sp>
+        <p:nvSpPr>
+          <p:cNvPr id="5" name="Rectangle: Rounded Corners 4">
+            <a:extLst>
+              <a:ext uri="{FF2B5EF4-FFF2-40B4-BE49-F238E27FC236}">
+                <a16:creationId xmlns:a16="http://schemas.microsoft.com/office/drawing/2014/main" id="{855FD758-8CA8-97F0-86A6-673795C8D55E}"/>
+              </a:ext>
+            </a:extLst>
+          </p:cNvPr>
+          <p:cNvSpPr/>
+          <p:nvPr/>
+        </p:nvSpPr>
+        <p:spPr>
+          <a:xfrm>
+            <a:off x="2359742" y="88490"/>
+            <a:ext cx="2408903" cy="6459794"/>
           </a:xfrm>
           <a:prstGeom prst="roundRect">
             <a:avLst/>
@@ -3770,53 +4242,88 @@
             <a:pPr algn="ctr"/>
             <a:r>
               <a:rPr lang="en-CA" dirty="0"/>
-              <a:t>Shader “Program”</a:t>
-            </a:r>
-          </a:p>
-          <a:p>
-            <a:pPr algn="ctr"/>
-            <a:endParaRPr lang="en-CA" dirty="0"/>
-          </a:p>
-          <a:p>
-            <a:pPr algn="ctr"/>
-            <a:endParaRPr lang="en-CA" dirty="0"/>
-          </a:p>
-          <a:p>
-            <a:pPr algn="ctr"/>
-            <a:endParaRPr lang="en-CA" dirty="0"/>
-          </a:p>
-          <a:p>
-            <a:pPr algn="ctr"/>
-            <a:endParaRPr lang="en-CA" dirty="0"/>
-          </a:p>
-          <a:p>
-            <a:pPr algn="ctr"/>
-            <a:endParaRPr lang="en-CA" dirty="0"/>
-          </a:p>
-          <a:p>
-            <a:pPr algn="ctr"/>
-            <a:endParaRPr lang="en-CA" dirty="0"/>
-          </a:p>
-          <a:p>
-            <a:pPr algn="ctr"/>
-            <a:endParaRPr lang="en-CA" dirty="0"/>
-          </a:p>
-          <a:p>
-            <a:pPr algn="ctr"/>
-            <a:endParaRPr lang="en-CA" dirty="0"/>
-          </a:p>
-          <a:p>
-            <a:pPr algn="ctr"/>
-            <a:endParaRPr lang="en-CA" dirty="0"/>
-          </a:p>
-        </p:txBody>
-      </p:sp>
-      <p:sp>
-        <p:nvSpPr>
-          <p:cNvPr id="9" name="Rectangle: Rounded Corners 8">
-            <a:extLst>
-              <a:ext uri="{FF2B5EF4-FFF2-40B4-BE49-F238E27FC236}">
-                <a16:creationId xmlns:a16="http://schemas.microsoft.com/office/drawing/2014/main" id="{C770166A-DA62-5E5D-EC57-615034048C5E}"/>
+              <a:t>CPU (C++)</a:t>
+            </a:r>
+          </a:p>
+          <a:p>
+            <a:pPr algn="ctr"/>
+            <a:endParaRPr lang="en-CA" dirty="0"/>
+          </a:p>
+          <a:p>
+            <a:pPr algn="ctr"/>
+            <a:endParaRPr lang="en-CA" dirty="0"/>
+          </a:p>
+          <a:p>
+            <a:pPr algn="ctr"/>
+            <a:endParaRPr lang="en-CA" dirty="0"/>
+          </a:p>
+          <a:p>
+            <a:pPr algn="ctr"/>
+            <a:endParaRPr lang="en-CA" dirty="0"/>
+          </a:p>
+          <a:p>
+            <a:pPr algn="ctr"/>
+            <a:endParaRPr lang="en-CA" dirty="0"/>
+          </a:p>
+          <a:p>
+            <a:pPr algn="ctr"/>
+            <a:endParaRPr lang="en-CA" dirty="0"/>
+          </a:p>
+          <a:p>
+            <a:pPr algn="ctr"/>
+            <a:endParaRPr lang="en-CA" dirty="0"/>
+          </a:p>
+          <a:p>
+            <a:pPr algn="ctr"/>
+            <a:endParaRPr lang="en-CA" dirty="0"/>
+          </a:p>
+          <a:p>
+            <a:pPr algn="ctr"/>
+            <a:endParaRPr lang="en-CA" dirty="0"/>
+          </a:p>
+          <a:p>
+            <a:pPr algn="ctr"/>
+            <a:endParaRPr lang="en-CA" dirty="0"/>
+          </a:p>
+          <a:p>
+            <a:pPr algn="ctr"/>
+            <a:endParaRPr lang="en-CA" dirty="0"/>
+          </a:p>
+          <a:p>
+            <a:pPr algn="ctr"/>
+            <a:endParaRPr lang="en-CA" dirty="0"/>
+          </a:p>
+          <a:p>
+            <a:pPr algn="ctr"/>
+            <a:endParaRPr lang="en-CA" dirty="0"/>
+          </a:p>
+          <a:p>
+            <a:pPr algn="ctr"/>
+            <a:endParaRPr lang="en-CA" dirty="0"/>
+          </a:p>
+          <a:p>
+            <a:pPr algn="ctr"/>
+            <a:endParaRPr lang="en-CA" dirty="0"/>
+          </a:p>
+          <a:p>
+            <a:pPr algn="ctr"/>
+            <a:endParaRPr lang="en-CA" dirty="0"/>
+          </a:p>
+          <a:p>
+            <a:pPr algn="ctr"/>
+            <a:r>
+              <a:rPr lang="en-CA" dirty="0"/>
+              <a:t> </a:t>
+            </a:r>
+          </a:p>
+        </p:txBody>
+      </p:sp>
+      <p:sp>
+        <p:nvSpPr>
+          <p:cNvPr id="4" name="Rectangle 3">
+            <a:extLst>
+              <a:ext uri="{FF2B5EF4-FFF2-40B4-BE49-F238E27FC236}">
+                <a16:creationId xmlns:a16="http://schemas.microsoft.com/office/drawing/2014/main" id="{9A6E1664-BDE9-C8D9-CFE3-3745CB0CEEB5}"/>
               </a:ext>
             </a:extLst>
           </p:cNvPr>
@@ -3825,22 +4332,71 @@
         </p:nvSpPr>
         <p:spPr>
           <a:xfrm>
-            <a:off x="9026013" y="2271253"/>
-            <a:ext cx="1986116" cy="835742"/>
+            <a:off x="3037034" y="1632155"/>
+            <a:ext cx="912126" cy="1666569"/>
+          </a:xfrm>
+          <a:prstGeom prst="rect">
+            <a:avLst/>
+          </a:prstGeom>
+        </p:spPr>
+        <p:style>
+          <a:lnRef idx="3">
+            <a:schemeClr val="lt1"/>
+          </a:lnRef>
+          <a:fillRef idx="1">
+            <a:schemeClr val="accent6"/>
+          </a:fillRef>
+          <a:effectRef idx="1">
+            <a:schemeClr val="accent6"/>
+          </a:effectRef>
+          <a:fontRef idx="minor">
+            <a:schemeClr val="lt1"/>
+          </a:fontRef>
+        </p:style>
+        <p:txBody>
+          <a:bodyPr rtlCol="0" anchor="ctr"/>
+          <a:lstStyle/>
+          <a:p>
+            <a:pPr algn="ctr"/>
+            <a:r>
+              <a:rPr lang="en-CA" dirty="0"/>
+              <a:t>RAM</a:t>
+            </a:r>
+          </a:p>
+        </p:txBody>
+      </p:sp>
+      <p:sp>
+        <p:nvSpPr>
+          <p:cNvPr id="6" name="Rectangle: Rounded Corners 5">
+            <a:extLst>
+              <a:ext uri="{FF2B5EF4-FFF2-40B4-BE49-F238E27FC236}">
+                <a16:creationId xmlns:a16="http://schemas.microsoft.com/office/drawing/2014/main" id="{A7AB6A8E-617B-EFE7-82EB-41E6C14BB692}"/>
+              </a:ext>
+            </a:extLst>
+          </p:cNvPr>
+          <p:cNvSpPr/>
+          <p:nvPr/>
+        </p:nvSpPr>
+        <p:spPr>
+          <a:xfrm>
+            <a:off x="5830530" y="88490"/>
+            <a:ext cx="5309418" cy="6459794"/>
           </a:xfrm>
           <a:prstGeom prst="roundRect">
             <a:avLst/>
           </a:prstGeom>
         </p:spPr>
         <p:style>
-          <a:lnRef idx="3">
-            <a:schemeClr val="lt1"/>
+          <a:lnRef idx="2">
+            <a:schemeClr val="accent1">
+              <a:shade val="15000"/>
+            </a:schemeClr>
           </a:lnRef>
           <a:fillRef idx="1">
-            <a:schemeClr val="accent4"/>
+            <a:schemeClr val="accent1"/>
           </a:fillRef>
-          <a:effectRef idx="1">
-            <a:schemeClr val="accent4"/>
+          <a:effectRef idx="0">
+            <a:schemeClr val="accent1"/>
           </a:effectRef>
           <a:fontRef idx="minor">
             <a:schemeClr val="lt1"/>
@@ -3852,22 +4408,86 @@
           <a:p>
             <a:pPr algn="ctr"/>
             <a:r>
-              <a:rPr lang="en-CA" dirty="0">
-                <a:solidFill>
-                  <a:schemeClr val="tx1"/>
-                </a:solidFill>
-              </a:rPr>
-              <a:t>Vertex</a:t>
-            </a:r>
-          </a:p>
-        </p:txBody>
-      </p:sp>
-      <p:sp>
-        <p:nvSpPr>
-          <p:cNvPr id="10" name="Rectangle: Rounded Corners 9">
-            <a:extLst>
-              <a:ext uri="{FF2B5EF4-FFF2-40B4-BE49-F238E27FC236}">
-                <a16:creationId xmlns:a16="http://schemas.microsoft.com/office/drawing/2014/main" id="{F55A8CC1-47C2-1E03-2710-00949FBA61EF}"/>
+              <a:rPr lang="en-CA" dirty="0"/>
+              <a:t>GPU</a:t>
+            </a:r>
+          </a:p>
+          <a:p>
+            <a:pPr algn="ctr"/>
+            <a:endParaRPr lang="en-CA" dirty="0"/>
+          </a:p>
+          <a:p>
+            <a:pPr algn="ctr"/>
+            <a:endParaRPr lang="en-CA" dirty="0"/>
+          </a:p>
+          <a:p>
+            <a:pPr algn="ctr"/>
+            <a:endParaRPr lang="en-CA" dirty="0"/>
+          </a:p>
+          <a:p>
+            <a:pPr algn="ctr"/>
+            <a:endParaRPr lang="en-CA" dirty="0"/>
+          </a:p>
+          <a:p>
+            <a:pPr algn="ctr"/>
+            <a:endParaRPr lang="en-CA" dirty="0"/>
+          </a:p>
+          <a:p>
+            <a:pPr algn="ctr"/>
+            <a:endParaRPr lang="en-CA" dirty="0"/>
+          </a:p>
+          <a:p>
+            <a:pPr algn="ctr"/>
+            <a:endParaRPr lang="en-CA" dirty="0"/>
+          </a:p>
+          <a:p>
+            <a:pPr algn="ctr"/>
+            <a:endParaRPr lang="en-CA" dirty="0"/>
+          </a:p>
+          <a:p>
+            <a:pPr algn="ctr"/>
+            <a:endParaRPr lang="en-CA" dirty="0"/>
+          </a:p>
+          <a:p>
+            <a:pPr algn="ctr"/>
+            <a:endParaRPr lang="en-CA" dirty="0"/>
+          </a:p>
+          <a:p>
+            <a:pPr algn="ctr"/>
+            <a:endParaRPr lang="en-CA" dirty="0"/>
+          </a:p>
+          <a:p>
+            <a:pPr algn="ctr"/>
+            <a:endParaRPr lang="en-CA" dirty="0"/>
+          </a:p>
+          <a:p>
+            <a:pPr algn="ctr"/>
+            <a:endParaRPr lang="en-CA" dirty="0"/>
+          </a:p>
+          <a:p>
+            <a:pPr algn="ctr"/>
+            <a:endParaRPr lang="en-CA" dirty="0"/>
+          </a:p>
+          <a:p>
+            <a:pPr algn="ctr"/>
+            <a:endParaRPr lang="en-CA" dirty="0"/>
+          </a:p>
+          <a:p>
+            <a:pPr algn="ctr"/>
+            <a:endParaRPr lang="en-CA" dirty="0"/>
+          </a:p>
+          <a:p>
+            <a:pPr algn="ctr"/>
+            <a:endParaRPr lang="en-CA" dirty="0"/>
+          </a:p>
+        </p:txBody>
+      </p:sp>
+      <p:sp>
+        <p:nvSpPr>
+          <p:cNvPr id="8" name="Arrow: Right 7">
+            <a:extLst>
+              <a:ext uri="{FF2B5EF4-FFF2-40B4-BE49-F238E27FC236}">
+                <a16:creationId xmlns:a16="http://schemas.microsoft.com/office/drawing/2014/main" id="{9E9D5935-7A52-C77B-8374-E864BCEE7462}"/>
               </a:ext>
             </a:extLst>
           </p:cNvPr>
@@ -3876,59 +4496,8 @@
         </p:nvSpPr>
         <p:spPr>
           <a:xfrm>
-            <a:off x="9026013" y="3298724"/>
-            <a:ext cx="1986116" cy="835742"/>
-          </a:xfrm>
-          <a:prstGeom prst="roundRect">
-            <a:avLst/>
-          </a:prstGeom>
-        </p:spPr>
-        <p:style>
-          <a:lnRef idx="3">
-            <a:schemeClr val="lt1"/>
-          </a:lnRef>
-          <a:fillRef idx="1">
-            <a:schemeClr val="accent4"/>
-          </a:fillRef>
-          <a:effectRef idx="1">
-            <a:schemeClr val="accent4"/>
-          </a:effectRef>
-          <a:fontRef idx="minor">
-            <a:schemeClr val="lt1"/>
-          </a:fontRef>
-        </p:style>
-        <p:txBody>
-          <a:bodyPr rtlCol="0" anchor="ctr"/>
-          <a:lstStyle/>
-          <a:p>
-            <a:pPr algn="ctr"/>
-            <a:r>
-              <a:rPr lang="en-CA" dirty="0">
-                <a:solidFill>
-                  <a:schemeClr val="tx1"/>
-                </a:solidFill>
-              </a:rPr>
-              <a:t>Fragment</a:t>
-            </a:r>
-          </a:p>
-        </p:txBody>
-      </p:sp>
-      <p:sp>
-        <p:nvSpPr>
-          <p:cNvPr id="12" name="Arrow: Right 11">
-            <a:extLst>
-              <a:ext uri="{FF2B5EF4-FFF2-40B4-BE49-F238E27FC236}">
-                <a16:creationId xmlns:a16="http://schemas.microsoft.com/office/drawing/2014/main" id="{A94E4D52-A290-E5D3-0494-1F5571B038C3}"/>
-              </a:ext>
-            </a:extLst>
-          </p:cNvPr>
-          <p:cNvSpPr/>
-          <p:nvPr/>
-        </p:nvSpPr>
-        <p:spPr>
-          <a:xfrm>
-            <a:off x="11611896" y="2571136"/>
-            <a:ext cx="2261420" cy="1219200"/>
+            <a:off x="4251364" y="2767079"/>
+            <a:ext cx="2273617" cy="1219200"/>
           </a:xfrm>
           <a:prstGeom prst="rightArrow">
             <a:avLst/>
@@ -3953,19 +4522,16 @@
           <a:lstStyle/>
           <a:p>
             <a:pPr algn="ctr"/>
-            <a:r>
-              <a:rPr lang="en-CA" dirty="0"/>
-              <a:t>To the screen (back buffer)</a:t>
-            </a:r>
-          </a:p>
-        </p:txBody>
-      </p:sp>
-      <p:sp>
-        <p:nvSpPr>
-          <p:cNvPr id="13" name="Arrow: Right 12">
-            <a:extLst>
-              <a:ext uri="{FF2B5EF4-FFF2-40B4-BE49-F238E27FC236}">
-                <a16:creationId xmlns:a16="http://schemas.microsoft.com/office/drawing/2014/main" id="{5F240329-D1AC-2AA6-9E5F-9F28FBD8DB21}"/>
+            <a:endParaRPr lang="en-CA"/>
+          </a:p>
+        </p:txBody>
+      </p:sp>
+      <p:sp>
+        <p:nvSpPr>
+          <p:cNvPr id="11" name="Rectangle: Rounded Corners 10">
+            <a:extLst>
+              <a:ext uri="{FF2B5EF4-FFF2-40B4-BE49-F238E27FC236}">
+                <a16:creationId xmlns:a16="http://schemas.microsoft.com/office/drawing/2014/main" id="{DD8208FC-83C2-3DB4-987C-E51904197546}"/>
               </a:ext>
             </a:extLst>
           </p:cNvPr>
@@ -3974,8 +4540,195 @@
         </p:nvSpPr>
         <p:spPr>
           <a:xfrm>
-            <a:off x="7977649" y="2531806"/>
-            <a:ext cx="1565787" cy="1219200"/>
+            <a:off x="8554065" y="1622323"/>
+            <a:ext cx="2792361" cy="2969343"/>
+          </a:xfrm>
+          <a:prstGeom prst="roundRect">
+            <a:avLst/>
+          </a:prstGeom>
+        </p:spPr>
+        <p:style>
+          <a:lnRef idx="2">
+            <a:schemeClr val="accent1">
+              <a:shade val="15000"/>
+            </a:schemeClr>
+          </a:lnRef>
+          <a:fillRef idx="1">
+            <a:schemeClr val="accent1"/>
+          </a:fillRef>
+          <a:effectRef idx="0">
+            <a:schemeClr val="accent1"/>
+          </a:effectRef>
+          <a:fontRef idx="minor">
+            <a:schemeClr val="lt1"/>
+          </a:fontRef>
+        </p:style>
+        <p:txBody>
+          <a:bodyPr rtlCol="0" anchor="ctr"/>
+          <a:lstStyle/>
+          <a:p>
+            <a:pPr algn="ctr"/>
+            <a:r>
+              <a:rPr lang="en-CA" dirty="0"/>
+              <a:t>Shader “Program”</a:t>
+            </a:r>
+          </a:p>
+          <a:p>
+            <a:pPr algn="ctr"/>
+            <a:endParaRPr lang="en-CA" dirty="0"/>
+          </a:p>
+          <a:p>
+            <a:pPr algn="ctr"/>
+            <a:endParaRPr lang="en-CA" dirty="0"/>
+          </a:p>
+          <a:p>
+            <a:pPr algn="ctr"/>
+            <a:endParaRPr lang="en-CA" dirty="0"/>
+          </a:p>
+          <a:p>
+            <a:pPr algn="ctr"/>
+            <a:endParaRPr lang="en-CA" dirty="0"/>
+          </a:p>
+          <a:p>
+            <a:pPr algn="ctr"/>
+            <a:endParaRPr lang="en-CA" dirty="0"/>
+          </a:p>
+          <a:p>
+            <a:pPr algn="ctr"/>
+            <a:endParaRPr lang="en-CA" dirty="0"/>
+          </a:p>
+          <a:p>
+            <a:pPr algn="ctr"/>
+            <a:endParaRPr lang="en-CA" dirty="0"/>
+          </a:p>
+          <a:p>
+            <a:pPr algn="ctr"/>
+            <a:endParaRPr lang="en-CA" dirty="0"/>
+          </a:p>
+          <a:p>
+            <a:pPr algn="ctr"/>
+            <a:endParaRPr lang="en-CA" dirty="0"/>
+          </a:p>
+        </p:txBody>
+      </p:sp>
+      <p:sp>
+        <p:nvSpPr>
+          <p:cNvPr id="9" name="Rectangle: Rounded Corners 8">
+            <a:extLst>
+              <a:ext uri="{FF2B5EF4-FFF2-40B4-BE49-F238E27FC236}">
+                <a16:creationId xmlns:a16="http://schemas.microsoft.com/office/drawing/2014/main" id="{C770166A-DA62-5E5D-EC57-615034048C5E}"/>
+              </a:ext>
+            </a:extLst>
+          </p:cNvPr>
+          <p:cNvSpPr/>
+          <p:nvPr/>
+        </p:nvSpPr>
+        <p:spPr>
+          <a:xfrm>
+            <a:off x="9026013" y="2271253"/>
+            <a:ext cx="1986116" cy="835742"/>
+          </a:xfrm>
+          <a:prstGeom prst="roundRect">
+            <a:avLst/>
+          </a:prstGeom>
+        </p:spPr>
+        <p:style>
+          <a:lnRef idx="3">
+            <a:schemeClr val="lt1"/>
+          </a:lnRef>
+          <a:fillRef idx="1">
+            <a:schemeClr val="accent4"/>
+          </a:fillRef>
+          <a:effectRef idx="1">
+            <a:schemeClr val="accent4"/>
+          </a:effectRef>
+          <a:fontRef idx="minor">
+            <a:schemeClr val="lt1"/>
+          </a:fontRef>
+        </p:style>
+        <p:txBody>
+          <a:bodyPr rtlCol="0" anchor="ctr"/>
+          <a:lstStyle/>
+          <a:p>
+            <a:pPr algn="ctr"/>
+            <a:r>
+              <a:rPr lang="en-CA" dirty="0">
+                <a:solidFill>
+                  <a:schemeClr val="tx1"/>
+                </a:solidFill>
+              </a:rPr>
+              <a:t>Vertex</a:t>
+            </a:r>
+          </a:p>
+        </p:txBody>
+      </p:sp>
+      <p:sp>
+        <p:nvSpPr>
+          <p:cNvPr id="10" name="Rectangle: Rounded Corners 9">
+            <a:extLst>
+              <a:ext uri="{FF2B5EF4-FFF2-40B4-BE49-F238E27FC236}">
+                <a16:creationId xmlns:a16="http://schemas.microsoft.com/office/drawing/2014/main" id="{F55A8CC1-47C2-1E03-2710-00949FBA61EF}"/>
+              </a:ext>
+            </a:extLst>
+          </p:cNvPr>
+          <p:cNvSpPr/>
+          <p:nvPr/>
+        </p:nvSpPr>
+        <p:spPr>
+          <a:xfrm>
+            <a:off x="9026013" y="3298724"/>
+            <a:ext cx="1986116" cy="835742"/>
+          </a:xfrm>
+          <a:prstGeom prst="roundRect">
+            <a:avLst/>
+          </a:prstGeom>
+        </p:spPr>
+        <p:style>
+          <a:lnRef idx="3">
+            <a:schemeClr val="lt1"/>
+          </a:lnRef>
+          <a:fillRef idx="1">
+            <a:schemeClr val="accent4"/>
+          </a:fillRef>
+          <a:effectRef idx="1">
+            <a:schemeClr val="accent4"/>
+          </a:effectRef>
+          <a:fontRef idx="minor">
+            <a:schemeClr val="lt1"/>
+          </a:fontRef>
+        </p:style>
+        <p:txBody>
+          <a:bodyPr rtlCol="0" anchor="ctr"/>
+          <a:lstStyle/>
+          <a:p>
+            <a:pPr algn="ctr"/>
+            <a:r>
+              <a:rPr lang="en-CA" dirty="0">
+                <a:solidFill>
+                  <a:schemeClr val="tx1"/>
+                </a:solidFill>
+              </a:rPr>
+              <a:t>Fragment</a:t>
+            </a:r>
+          </a:p>
+        </p:txBody>
+      </p:sp>
+      <p:sp>
+        <p:nvSpPr>
+          <p:cNvPr id="12" name="Arrow: Right 11">
+            <a:extLst>
+              <a:ext uri="{FF2B5EF4-FFF2-40B4-BE49-F238E27FC236}">
+                <a16:creationId xmlns:a16="http://schemas.microsoft.com/office/drawing/2014/main" id="{A94E4D52-A290-E5D3-0494-1F5571B038C3}"/>
+              </a:ext>
+            </a:extLst>
+          </p:cNvPr>
+          <p:cNvSpPr/>
+          <p:nvPr/>
+        </p:nvSpPr>
+        <p:spPr>
+          <a:xfrm>
+            <a:off x="11611896" y="2571136"/>
+            <a:ext cx="2261420" cy="1219200"/>
           </a:xfrm>
           <a:prstGeom prst="rightArrow">
             <a:avLst/>
@@ -4002,17 +4755,17 @@
             <a:pPr algn="ctr"/>
             <a:r>
               <a:rPr lang="en-CA" dirty="0"/>
-              <a:t>VL</a:t>
-            </a:r>
-          </a:p>
-        </p:txBody>
-      </p:sp>
-      <p:sp>
-        <p:nvSpPr>
-          <p:cNvPr id="14" name="Rectangle 13">
-            <a:extLst>
-              <a:ext uri="{FF2B5EF4-FFF2-40B4-BE49-F238E27FC236}">
-                <a16:creationId xmlns:a16="http://schemas.microsoft.com/office/drawing/2014/main" id="{FEF9F6F0-10D3-CC44-912C-80D329FB5F3C}"/>
+              <a:t>To the screen (back buffer)</a:t>
+            </a:r>
+          </a:p>
+        </p:txBody>
+      </p:sp>
+      <p:sp>
+        <p:nvSpPr>
+          <p:cNvPr id="13" name="Arrow: Right 12">
+            <a:extLst>
+              <a:ext uri="{FF2B5EF4-FFF2-40B4-BE49-F238E27FC236}">
+                <a16:creationId xmlns:a16="http://schemas.microsoft.com/office/drawing/2014/main" id="{5F240329-D1AC-2AA6-9E5F-9F28FBD8DB21}"/>
               </a:ext>
             </a:extLst>
           </p:cNvPr>
@@ -4021,55 +4774,8 @@
         </p:nvSpPr>
         <p:spPr>
           <a:xfrm>
-            <a:off x="-2340076" y="1543666"/>
-            <a:ext cx="1779638" cy="3962400"/>
-          </a:xfrm>
-          <a:prstGeom prst="rect">
-            <a:avLst/>
-          </a:prstGeom>
-        </p:spPr>
-        <p:style>
-          <a:lnRef idx="3">
-            <a:schemeClr val="lt1"/>
-          </a:lnRef>
-          <a:fillRef idx="1">
-            <a:schemeClr val="accent6"/>
-          </a:fillRef>
-          <a:effectRef idx="1">
-            <a:schemeClr val="accent6"/>
-          </a:effectRef>
-          <a:fontRef idx="minor">
-            <a:schemeClr val="lt1"/>
-          </a:fontRef>
-        </p:style>
-        <p:txBody>
-          <a:bodyPr rtlCol="0" anchor="ctr"/>
-          <a:lstStyle/>
-          <a:p>
-            <a:pPr algn="ctr"/>
-            <a:r>
-              <a:rPr lang="en-CA" dirty="0"/>
-              <a:t>File</a:t>
-            </a:r>
-          </a:p>
-        </p:txBody>
-      </p:sp>
-      <p:sp>
-        <p:nvSpPr>
-          <p:cNvPr id="15" name="Arrow: Right 14">
-            <a:extLst>
-              <a:ext uri="{FF2B5EF4-FFF2-40B4-BE49-F238E27FC236}">
-                <a16:creationId xmlns:a16="http://schemas.microsoft.com/office/drawing/2014/main" id="{54854930-83AB-D2BB-035E-DDEA1FA8DE37}"/>
-              </a:ext>
-            </a:extLst>
-          </p:cNvPr>
-          <p:cNvSpPr/>
-          <p:nvPr/>
-        </p:nvSpPr>
-        <p:spPr>
-          <a:xfrm>
-            <a:off x="-2025628" y="2991655"/>
-            <a:ext cx="1499418" cy="1219200"/>
+            <a:off x="7977649" y="2531806"/>
+            <a:ext cx="1565787" cy="1219200"/>
           </a:xfrm>
           <a:prstGeom prst="rightArrow">
             <a:avLst/>
@@ -4094,16 +4800,19 @@
           <a:lstStyle/>
           <a:p>
             <a:pPr algn="ctr"/>
-            <a:endParaRPr lang="en-CA"/>
-          </a:p>
-        </p:txBody>
-      </p:sp>
-      <p:sp>
-        <p:nvSpPr>
-          <p:cNvPr id="2" name="Rectangle 1">
-            <a:extLst>
-              <a:ext uri="{FF2B5EF4-FFF2-40B4-BE49-F238E27FC236}">
-                <a16:creationId xmlns:a16="http://schemas.microsoft.com/office/drawing/2014/main" id="{8ACAC186-645C-EFF0-E5FA-8B3A73966620}"/>
+            <a:r>
+              <a:rPr lang="en-CA" dirty="0"/>
+              <a:t>VL</a:t>
+            </a:r>
+          </a:p>
+        </p:txBody>
+      </p:sp>
+      <p:sp>
+        <p:nvSpPr>
+          <p:cNvPr id="14" name="Rectangle 13">
+            <a:extLst>
+              <a:ext uri="{FF2B5EF4-FFF2-40B4-BE49-F238E27FC236}">
+                <a16:creationId xmlns:a16="http://schemas.microsoft.com/office/drawing/2014/main" id="{FEF9F6F0-10D3-CC44-912C-80D329FB5F3C}"/>
               </a:ext>
             </a:extLst>
           </p:cNvPr>
@@ -4112,8 +4821,8 @@
         </p:nvSpPr>
         <p:spPr>
           <a:xfrm>
-            <a:off x="6125500" y="1622323"/>
-            <a:ext cx="929146" cy="3962400"/>
+            <a:off x="-3648291" y="1570002"/>
+            <a:ext cx="1779638" cy="3962400"/>
           </a:xfrm>
           <a:prstGeom prst="rect">
             <a:avLst/>
@@ -4140,6 +4849,198 @@
             <a:pPr algn="ctr"/>
             <a:r>
               <a:rPr lang="en-CA" dirty="0"/>
+              <a:t>File</a:t>
+            </a:r>
+          </a:p>
+        </p:txBody>
+      </p:sp>
+      <p:sp>
+        <p:nvSpPr>
+          <p:cNvPr id="15" name="Arrow: Right 14">
+            <a:extLst>
+              <a:ext uri="{FF2B5EF4-FFF2-40B4-BE49-F238E27FC236}">
+                <a16:creationId xmlns:a16="http://schemas.microsoft.com/office/drawing/2014/main" id="{54854930-83AB-D2BB-035E-DDEA1FA8DE37}"/>
+              </a:ext>
+            </a:extLst>
+          </p:cNvPr>
+          <p:cNvSpPr/>
+          <p:nvPr/>
+        </p:nvSpPr>
+        <p:spPr>
+          <a:xfrm>
+            <a:off x="-2010696" y="2767079"/>
+            <a:ext cx="1499418" cy="1219200"/>
+          </a:xfrm>
+          <a:prstGeom prst="rightArrow">
+            <a:avLst/>
+          </a:prstGeom>
+        </p:spPr>
+        <p:style>
+          <a:lnRef idx="1">
+            <a:schemeClr val="accent2"/>
+          </a:lnRef>
+          <a:fillRef idx="3">
+            <a:schemeClr val="accent2"/>
+          </a:fillRef>
+          <a:effectRef idx="2">
+            <a:schemeClr val="accent2"/>
+          </a:effectRef>
+          <a:fontRef idx="minor">
+            <a:schemeClr val="lt1"/>
+          </a:fontRef>
+        </p:style>
+        <p:txBody>
+          <a:bodyPr rtlCol="0" anchor="ctr"/>
+          <a:lstStyle/>
+          <a:p>
+            <a:pPr algn="ctr"/>
+            <a:endParaRPr lang="en-CA"/>
+          </a:p>
+        </p:txBody>
+      </p:sp>
+      <p:sp>
+        <p:nvSpPr>
+          <p:cNvPr id="2" name="Rectangle 1">
+            <a:extLst>
+              <a:ext uri="{FF2B5EF4-FFF2-40B4-BE49-F238E27FC236}">
+                <a16:creationId xmlns:a16="http://schemas.microsoft.com/office/drawing/2014/main" id="{8ACAC186-645C-EFF0-E5FA-8B3A73966620}"/>
+              </a:ext>
+            </a:extLst>
+          </p:cNvPr>
+          <p:cNvSpPr/>
+          <p:nvPr/>
+        </p:nvSpPr>
+        <p:spPr>
+          <a:xfrm>
+            <a:off x="6629404" y="1017639"/>
+            <a:ext cx="929146" cy="1981200"/>
+          </a:xfrm>
+          <a:prstGeom prst="rect">
+            <a:avLst/>
+          </a:prstGeom>
+        </p:spPr>
+        <p:style>
+          <a:lnRef idx="3">
+            <a:schemeClr val="lt1"/>
+          </a:lnRef>
+          <a:fillRef idx="1">
+            <a:schemeClr val="accent6"/>
+          </a:fillRef>
+          <a:effectRef idx="1">
+            <a:schemeClr val="accent6"/>
+          </a:effectRef>
+          <a:fontRef idx="minor">
+            <a:schemeClr val="lt1"/>
+          </a:fontRef>
+        </p:style>
+        <p:txBody>
+          <a:bodyPr rtlCol="0" anchor="ctr"/>
+          <a:lstStyle/>
+          <a:p>
+            <a:pPr algn="ctr"/>
+            <a:r>
+              <a:rPr lang="en-CA" dirty="0"/>
+              <a:t>Vertex</a:t>
+            </a:r>
+          </a:p>
+          <a:p>
+            <a:pPr algn="ctr"/>
+            <a:r>
+              <a:rPr lang="en-CA" dirty="0"/>
+              <a:t>buffer</a:t>
+            </a:r>
+          </a:p>
+        </p:txBody>
+      </p:sp>
+      <p:sp>
+        <p:nvSpPr>
+          <p:cNvPr id="3" name="Rectangle 2">
+            <a:extLst>
+              <a:ext uri="{FF2B5EF4-FFF2-40B4-BE49-F238E27FC236}">
+                <a16:creationId xmlns:a16="http://schemas.microsoft.com/office/drawing/2014/main" id="{F79CD240-80F7-5F46-E22C-4FCFDDA86F96}"/>
+              </a:ext>
+            </a:extLst>
+          </p:cNvPr>
+          <p:cNvSpPr/>
+          <p:nvPr/>
+        </p:nvSpPr>
+        <p:spPr>
+          <a:xfrm>
+            <a:off x="3060294" y="3716595"/>
+            <a:ext cx="912126" cy="1666569"/>
+          </a:xfrm>
+          <a:prstGeom prst="rect">
+            <a:avLst/>
+          </a:prstGeom>
+        </p:spPr>
+        <p:style>
+          <a:lnRef idx="3">
+            <a:schemeClr val="lt1"/>
+          </a:lnRef>
+          <a:fillRef idx="1">
+            <a:schemeClr val="accent6"/>
+          </a:fillRef>
+          <a:effectRef idx="1">
+            <a:schemeClr val="accent6"/>
+          </a:effectRef>
+          <a:fontRef idx="minor">
+            <a:schemeClr val="lt1"/>
+          </a:fontRef>
+        </p:style>
+        <p:txBody>
+          <a:bodyPr rtlCol="0" anchor="ctr"/>
+          <a:lstStyle/>
+          <a:p>
+            <a:pPr algn="ctr"/>
+            <a:r>
+              <a:rPr lang="en-CA" dirty="0"/>
+              <a:t>RAM</a:t>
+            </a:r>
+          </a:p>
+        </p:txBody>
+      </p:sp>
+      <p:sp>
+        <p:nvSpPr>
+          <p:cNvPr id="7" name="Rectangle 6">
+            <a:extLst>
+              <a:ext uri="{FF2B5EF4-FFF2-40B4-BE49-F238E27FC236}">
+                <a16:creationId xmlns:a16="http://schemas.microsoft.com/office/drawing/2014/main" id="{B2CC7C08-B939-4B0C-4C84-134CAD938771}"/>
+              </a:ext>
+            </a:extLst>
+          </p:cNvPr>
+          <p:cNvSpPr/>
+          <p:nvPr/>
+        </p:nvSpPr>
+        <p:spPr>
+          <a:xfrm>
+            <a:off x="6563034" y="3608439"/>
+            <a:ext cx="929146" cy="1981200"/>
+          </a:xfrm>
+          <a:prstGeom prst="rect">
+            <a:avLst/>
+          </a:prstGeom>
+        </p:spPr>
+        <p:style>
+          <a:lnRef idx="3">
+            <a:schemeClr val="lt1"/>
+          </a:lnRef>
+          <a:fillRef idx="1">
+            <a:schemeClr val="accent6"/>
+          </a:fillRef>
+          <a:effectRef idx="1">
+            <a:schemeClr val="accent6"/>
+          </a:effectRef>
+          <a:fontRef idx="minor">
+            <a:schemeClr val="lt1"/>
+          </a:fontRef>
+        </p:style>
+        <p:txBody>
+          <a:bodyPr rtlCol="0" anchor="ctr"/>
+          <a:lstStyle/>
+          <a:p>
+            <a:pPr algn="ctr"/>
+            <a:r>
+              <a:rPr lang="en-CA" dirty="0"/>
               <a:t>Vertex</a:t>
             </a:r>
           </a:p>
@@ -4155,7 +5056,2861 @@
     </p:spTree>
     <p:extLst>
       <p:ext uri="{BB962C8B-B14F-4D97-AF65-F5344CB8AC3E}">
-        <p14:creationId xmlns:p14="http://schemas.microsoft.com/office/powerpoint/2010/main" val="800627848"/>
+        <p14:creationId xmlns:p14="http://schemas.microsoft.com/office/powerpoint/2010/main" val="3653337105"/>
+      </p:ext>
+    </p:extLst>
+  </p:cSld>
+  <p:clrMapOvr>
+    <a:masterClrMapping/>
+  </p:clrMapOvr>
+</p:sld>
+</file>
+
+<file path=ppt/slides/slide3.xml><?xml version="1.0" encoding="utf-8"?>
+<p:sld xmlns:a="http://schemas.openxmlformats.org/drawingml/2006/main" xmlns:r="http://schemas.openxmlformats.org/officeDocument/2006/relationships" xmlns:p="http://schemas.openxmlformats.org/presentationml/2006/main">
+  <p:cSld>
+    <p:spTree>
+      <p:nvGrpSpPr>
+        <p:cNvPr id="1" name=""/>
+        <p:cNvGrpSpPr/>
+        <p:nvPr/>
+      </p:nvGrpSpPr>
+      <p:grpSpPr>
+        <a:xfrm>
+          <a:off x="0" y="0"/>
+          <a:ext cx="0" cy="0"/>
+          <a:chOff x="0" y="0"/>
+          <a:chExt cx="0" cy="0"/>
+        </a:xfrm>
+      </p:grpSpPr>
+      <p:sp>
+        <p:nvSpPr>
+          <p:cNvPr id="5" name="Rectangle: Rounded Corners 4">
+            <a:extLst>
+              <a:ext uri="{FF2B5EF4-FFF2-40B4-BE49-F238E27FC236}">
+                <a16:creationId xmlns:a16="http://schemas.microsoft.com/office/drawing/2014/main" id="{855FD758-8CA8-97F0-86A6-673795C8D55E}"/>
+              </a:ext>
+            </a:extLst>
+          </p:cNvPr>
+          <p:cNvSpPr/>
+          <p:nvPr/>
+        </p:nvSpPr>
+        <p:spPr>
+          <a:xfrm>
+            <a:off x="1292596" y="88490"/>
+            <a:ext cx="3476050" cy="6459794"/>
+          </a:xfrm>
+          <a:prstGeom prst="roundRect">
+            <a:avLst/>
+          </a:prstGeom>
+        </p:spPr>
+        <p:style>
+          <a:lnRef idx="2">
+            <a:schemeClr val="accent1">
+              <a:shade val="15000"/>
+            </a:schemeClr>
+          </a:lnRef>
+          <a:fillRef idx="1">
+            <a:schemeClr val="accent1"/>
+          </a:fillRef>
+          <a:effectRef idx="0">
+            <a:schemeClr val="accent1"/>
+          </a:effectRef>
+          <a:fontRef idx="minor">
+            <a:schemeClr val="lt1"/>
+          </a:fontRef>
+        </p:style>
+        <p:txBody>
+          <a:bodyPr rtlCol="0" anchor="ctr"/>
+          <a:lstStyle/>
+          <a:p>
+            <a:pPr algn="ctr"/>
+            <a:r>
+              <a:rPr lang="en-CA" dirty="0"/>
+              <a:t>CPU (C++)</a:t>
+            </a:r>
+          </a:p>
+          <a:p>
+            <a:pPr algn="ctr"/>
+            <a:endParaRPr lang="en-CA" dirty="0"/>
+          </a:p>
+          <a:p>
+            <a:pPr algn="ctr"/>
+            <a:endParaRPr lang="en-CA" dirty="0"/>
+          </a:p>
+          <a:p>
+            <a:pPr algn="ctr"/>
+            <a:endParaRPr lang="en-CA" dirty="0"/>
+          </a:p>
+          <a:p>
+            <a:pPr algn="ctr"/>
+            <a:endParaRPr lang="en-CA" dirty="0"/>
+          </a:p>
+          <a:p>
+            <a:pPr algn="ctr"/>
+            <a:endParaRPr lang="en-CA" dirty="0"/>
+          </a:p>
+          <a:p>
+            <a:pPr algn="ctr"/>
+            <a:endParaRPr lang="en-CA" dirty="0"/>
+          </a:p>
+          <a:p>
+            <a:pPr algn="ctr"/>
+            <a:endParaRPr lang="en-CA" dirty="0"/>
+          </a:p>
+          <a:p>
+            <a:pPr algn="ctr"/>
+            <a:endParaRPr lang="en-CA" dirty="0"/>
+          </a:p>
+          <a:p>
+            <a:pPr algn="ctr"/>
+            <a:endParaRPr lang="en-CA" dirty="0"/>
+          </a:p>
+          <a:p>
+            <a:pPr algn="ctr"/>
+            <a:endParaRPr lang="en-CA" dirty="0"/>
+          </a:p>
+          <a:p>
+            <a:pPr algn="ctr"/>
+            <a:endParaRPr lang="en-CA" dirty="0"/>
+          </a:p>
+          <a:p>
+            <a:pPr algn="ctr"/>
+            <a:endParaRPr lang="en-CA" dirty="0"/>
+          </a:p>
+          <a:p>
+            <a:pPr algn="ctr"/>
+            <a:endParaRPr lang="en-CA" dirty="0"/>
+          </a:p>
+          <a:p>
+            <a:pPr algn="ctr"/>
+            <a:endParaRPr lang="en-CA" dirty="0"/>
+          </a:p>
+          <a:p>
+            <a:pPr algn="ctr"/>
+            <a:endParaRPr lang="en-CA" dirty="0"/>
+          </a:p>
+          <a:p>
+            <a:pPr algn="ctr"/>
+            <a:endParaRPr lang="en-CA" dirty="0"/>
+          </a:p>
+          <a:p>
+            <a:pPr algn="ctr"/>
+            <a:r>
+              <a:rPr lang="en-CA" dirty="0"/>
+              <a:t> </a:t>
+            </a:r>
+          </a:p>
+        </p:txBody>
+      </p:sp>
+      <p:sp>
+        <p:nvSpPr>
+          <p:cNvPr id="4" name="Rectangle 3">
+            <a:extLst>
+              <a:ext uri="{FF2B5EF4-FFF2-40B4-BE49-F238E27FC236}">
+                <a16:creationId xmlns:a16="http://schemas.microsoft.com/office/drawing/2014/main" id="{9A6E1664-BDE9-C8D9-CFE3-3745CB0CEEB5}"/>
+              </a:ext>
+            </a:extLst>
+          </p:cNvPr>
+          <p:cNvSpPr/>
+          <p:nvPr/>
+        </p:nvSpPr>
+        <p:spPr>
+          <a:xfrm>
+            <a:off x="1490659" y="1423219"/>
+            <a:ext cx="1031434" cy="2005780"/>
+          </a:xfrm>
+          <a:prstGeom prst="rect">
+            <a:avLst/>
+          </a:prstGeom>
+        </p:spPr>
+        <p:style>
+          <a:lnRef idx="0">
+            <a:schemeClr val="accent4"/>
+          </a:lnRef>
+          <a:fillRef idx="3">
+            <a:schemeClr val="accent4"/>
+          </a:fillRef>
+          <a:effectRef idx="3">
+            <a:schemeClr val="accent4"/>
+          </a:effectRef>
+          <a:fontRef idx="minor">
+            <a:schemeClr val="lt1"/>
+          </a:fontRef>
+        </p:style>
+        <p:txBody>
+          <a:bodyPr rtlCol="0" anchor="ctr"/>
+          <a:lstStyle/>
+          <a:p>
+            <a:pPr algn="ctr"/>
+            <a:r>
+              <a:rPr lang="en-CA" dirty="0"/>
+              <a:t>Vertices</a:t>
+            </a:r>
+          </a:p>
+        </p:txBody>
+      </p:sp>
+      <p:sp>
+        <p:nvSpPr>
+          <p:cNvPr id="6" name="Rectangle: Rounded Corners 5">
+            <a:extLst>
+              <a:ext uri="{FF2B5EF4-FFF2-40B4-BE49-F238E27FC236}">
+                <a16:creationId xmlns:a16="http://schemas.microsoft.com/office/drawing/2014/main" id="{A7AB6A8E-617B-EFE7-82EB-41E6C14BB692}"/>
+              </a:ext>
+            </a:extLst>
+          </p:cNvPr>
+          <p:cNvSpPr/>
+          <p:nvPr/>
+        </p:nvSpPr>
+        <p:spPr>
+          <a:xfrm>
+            <a:off x="5830530" y="88490"/>
+            <a:ext cx="5309418" cy="6459794"/>
+          </a:xfrm>
+          <a:prstGeom prst="roundRect">
+            <a:avLst/>
+          </a:prstGeom>
+        </p:spPr>
+        <p:style>
+          <a:lnRef idx="2">
+            <a:schemeClr val="accent1">
+              <a:shade val="15000"/>
+            </a:schemeClr>
+          </a:lnRef>
+          <a:fillRef idx="1">
+            <a:schemeClr val="accent1"/>
+          </a:fillRef>
+          <a:effectRef idx="0">
+            <a:schemeClr val="accent1"/>
+          </a:effectRef>
+          <a:fontRef idx="minor">
+            <a:schemeClr val="lt1"/>
+          </a:fontRef>
+        </p:style>
+        <p:txBody>
+          <a:bodyPr rtlCol="0" anchor="ctr"/>
+          <a:lstStyle/>
+          <a:p>
+            <a:pPr algn="ctr"/>
+            <a:r>
+              <a:rPr lang="en-CA" dirty="0"/>
+              <a:t>GPU</a:t>
+            </a:r>
+          </a:p>
+          <a:p>
+            <a:pPr algn="ctr"/>
+            <a:endParaRPr lang="en-CA" dirty="0"/>
+          </a:p>
+          <a:p>
+            <a:pPr algn="ctr"/>
+            <a:endParaRPr lang="en-CA" dirty="0"/>
+          </a:p>
+          <a:p>
+            <a:pPr algn="ctr"/>
+            <a:endParaRPr lang="en-CA" dirty="0"/>
+          </a:p>
+          <a:p>
+            <a:pPr algn="ctr"/>
+            <a:endParaRPr lang="en-CA" dirty="0"/>
+          </a:p>
+          <a:p>
+            <a:pPr algn="ctr"/>
+            <a:endParaRPr lang="en-CA" dirty="0"/>
+          </a:p>
+          <a:p>
+            <a:pPr algn="ctr"/>
+            <a:endParaRPr lang="en-CA" dirty="0"/>
+          </a:p>
+          <a:p>
+            <a:pPr algn="ctr"/>
+            <a:endParaRPr lang="en-CA" dirty="0"/>
+          </a:p>
+          <a:p>
+            <a:pPr algn="ctr"/>
+            <a:endParaRPr lang="en-CA" dirty="0"/>
+          </a:p>
+          <a:p>
+            <a:pPr algn="ctr"/>
+            <a:endParaRPr lang="en-CA" dirty="0"/>
+          </a:p>
+          <a:p>
+            <a:pPr algn="ctr"/>
+            <a:endParaRPr lang="en-CA" dirty="0"/>
+          </a:p>
+          <a:p>
+            <a:pPr algn="ctr"/>
+            <a:endParaRPr lang="en-CA" dirty="0"/>
+          </a:p>
+          <a:p>
+            <a:pPr algn="ctr"/>
+            <a:endParaRPr lang="en-CA" dirty="0"/>
+          </a:p>
+          <a:p>
+            <a:pPr algn="ctr"/>
+            <a:endParaRPr lang="en-CA" dirty="0"/>
+          </a:p>
+          <a:p>
+            <a:pPr algn="ctr"/>
+            <a:endParaRPr lang="en-CA" dirty="0"/>
+          </a:p>
+          <a:p>
+            <a:pPr algn="ctr"/>
+            <a:endParaRPr lang="en-CA" dirty="0"/>
+          </a:p>
+          <a:p>
+            <a:pPr algn="ctr"/>
+            <a:endParaRPr lang="en-CA" dirty="0"/>
+          </a:p>
+          <a:p>
+            <a:pPr algn="ctr"/>
+            <a:endParaRPr lang="en-CA" dirty="0"/>
+          </a:p>
+        </p:txBody>
+      </p:sp>
+      <p:sp>
+        <p:nvSpPr>
+          <p:cNvPr id="8" name="Arrow: Right 7">
+            <a:extLst>
+              <a:ext uri="{FF2B5EF4-FFF2-40B4-BE49-F238E27FC236}">
+                <a16:creationId xmlns:a16="http://schemas.microsoft.com/office/drawing/2014/main" id="{9E9D5935-7A52-C77B-8374-E864BCEE7462}"/>
+              </a:ext>
+            </a:extLst>
+          </p:cNvPr>
+          <p:cNvSpPr/>
+          <p:nvPr/>
+        </p:nvSpPr>
+        <p:spPr>
+          <a:xfrm>
+            <a:off x="4251364" y="2767079"/>
+            <a:ext cx="2273617" cy="1219200"/>
+          </a:xfrm>
+          <a:prstGeom prst="rightArrow">
+            <a:avLst/>
+          </a:prstGeom>
+        </p:spPr>
+        <p:style>
+          <a:lnRef idx="1">
+            <a:schemeClr val="accent2"/>
+          </a:lnRef>
+          <a:fillRef idx="3">
+            <a:schemeClr val="accent2"/>
+          </a:fillRef>
+          <a:effectRef idx="2">
+            <a:schemeClr val="accent2"/>
+          </a:effectRef>
+          <a:fontRef idx="minor">
+            <a:schemeClr val="lt1"/>
+          </a:fontRef>
+        </p:style>
+        <p:txBody>
+          <a:bodyPr rtlCol="0" anchor="ctr"/>
+          <a:lstStyle/>
+          <a:p>
+            <a:pPr algn="ctr"/>
+            <a:endParaRPr lang="en-CA"/>
+          </a:p>
+        </p:txBody>
+      </p:sp>
+      <p:sp>
+        <p:nvSpPr>
+          <p:cNvPr id="11" name="Rectangle: Rounded Corners 10">
+            <a:extLst>
+              <a:ext uri="{FF2B5EF4-FFF2-40B4-BE49-F238E27FC236}">
+                <a16:creationId xmlns:a16="http://schemas.microsoft.com/office/drawing/2014/main" id="{DD8208FC-83C2-3DB4-987C-E51904197546}"/>
+              </a:ext>
+            </a:extLst>
+          </p:cNvPr>
+          <p:cNvSpPr/>
+          <p:nvPr/>
+        </p:nvSpPr>
+        <p:spPr>
+          <a:xfrm>
+            <a:off x="8554065" y="1622323"/>
+            <a:ext cx="2792361" cy="2969343"/>
+          </a:xfrm>
+          <a:prstGeom prst="roundRect">
+            <a:avLst/>
+          </a:prstGeom>
+        </p:spPr>
+        <p:style>
+          <a:lnRef idx="2">
+            <a:schemeClr val="accent1">
+              <a:shade val="15000"/>
+            </a:schemeClr>
+          </a:lnRef>
+          <a:fillRef idx="1">
+            <a:schemeClr val="accent1"/>
+          </a:fillRef>
+          <a:effectRef idx="0">
+            <a:schemeClr val="accent1"/>
+          </a:effectRef>
+          <a:fontRef idx="minor">
+            <a:schemeClr val="lt1"/>
+          </a:fontRef>
+        </p:style>
+        <p:txBody>
+          <a:bodyPr rtlCol="0" anchor="ctr"/>
+          <a:lstStyle/>
+          <a:p>
+            <a:pPr algn="ctr"/>
+            <a:r>
+              <a:rPr lang="en-CA" dirty="0"/>
+              <a:t>Shader “Program”</a:t>
+            </a:r>
+          </a:p>
+          <a:p>
+            <a:pPr algn="ctr"/>
+            <a:endParaRPr lang="en-CA" dirty="0"/>
+          </a:p>
+          <a:p>
+            <a:pPr algn="ctr"/>
+            <a:endParaRPr lang="en-CA" dirty="0"/>
+          </a:p>
+          <a:p>
+            <a:pPr algn="ctr"/>
+            <a:endParaRPr lang="en-CA" dirty="0"/>
+          </a:p>
+          <a:p>
+            <a:pPr algn="ctr"/>
+            <a:endParaRPr lang="en-CA" dirty="0"/>
+          </a:p>
+          <a:p>
+            <a:pPr algn="ctr"/>
+            <a:endParaRPr lang="en-CA" dirty="0"/>
+          </a:p>
+          <a:p>
+            <a:pPr algn="ctr"/>
+            <a:endParaRPr lang="en-CA" dirty="0"/>
+          </a:p>
+          <a:p>
+            <a:pPr algn="ctr"/>
+            <a:endParaRPr lang="en-CA" dirty="0"/>
+          </a:p>
+          <a:p>
+            <a:pPr algn="ctr"/>
+            <a:endParaRPr lang="en-CA" dirty="0"/>
+          </a:p>
+          <a:p>
+            <a:pPr algn="ctr"/>
+            <a:endParaRPr lang="en-CA" dirty="0"/>
+          </a:p>
+        </p:txBody>
+      </p:sp>
+      <p:sp>
+        <p:nvSpPr>
+          <p:cNvPr id="9" name="Rectangle: Rounded Corners 8">
+            <a:extLst>
+              <a:ext uri="{FF2B5EF4-FFF2-40B4-BE49-F238E27FC236}">
+                <a16:creationId xmlns:a16="http://schemas.microsoft.com/office/drawing/2014/main" id="{C770166A-DA62-5E5D-EC57-615034048C5E}"/>
+              </a:ext>
+            </a:extLst>
+          </p:cNvPr>
+          <p:cNvSpPr/>
+          <p:nvPr/>
+        </p:nvSpPr>
+        <p:spPr>
+          <a:xfrm>
+            <a:off x="9026013" y="2271253"/>
+            <a:ext cx="1986116" cy="835742"/>
+          </a:xfrm>
+          <a:prstGeom prst="roundRect">
+            <a:avLst/>
+          </a:prstGeom>
+        </p:spPr>
+        <p:style>
+          <a:lnRef idx="3">
+            <a:schemeClr val="lt1"/>
+          </a:lnRef>
+          <a:fillRef idx="1">
+            <a:schemeClr val="accent4"/>
+          </a:fillRef>
+          <a:effectRef idx="1">
+            <a:schemeClr val="accent4"/>
+          </a:effectRef>
+          <a:fontRef idx="minor">
+            <a:schemeClr val="lt1"/>
+          </a:fontRef>
+        </p:style>
+        <p:txBody>
+          <a:bodyPr rtlCol="0" anchor="ctr"/>
+          <a:lstStyle/>
+          <a:p>
+            <a:pPr algn="ctr"/>
+            <a:r>
+              <a:rPr lang="en-CA" dirty="0">
+                <a:solidFill>
+                  <a:schemeClr val="tx1"/>
+                </a:solidFill>
+              </a:rPr>
+              <a:t>Vertex</a:t>
+            </a:r>
+          </a:p>
+        </p:txBody>
+      </p:sp>
+      <p:sp>
+        <p:nvSpPr>
+          <p:cNvPr id="10" name="Rectangle: Rounded Corners 9">
+            <a:extLst>
+              <a:ext uri="{FF2B5EF4-FFF2-40B4-BE49-F238E27FC236}">
+                <a16:creationId xmlns:a16="http://schemas.microsoft.com/office/drawing/2014/main" id="{F55A8CC1-47C2-1E03-2710-00949FBA61EF}"/>
+              </a:ext>
+            </a:extLst>
+          </p:cNvPr>
+          <p:cNvSpPr/>
+          <p:nvPr/>
+        </p:nvSpPr>
+        <p:spPr>
+          <a:xfrm>
+            <a:off x="9026013" y="3298724"/>
+            <a:ext cx="1986116" cy="835742"/>
+          </a:xfrm>
+          <a:prstGeom prst="roundRect">
+            <a:avLst/>
+          </a:prstGeom>
+        </p:spPr>
+        <p:style>
+          <a:lnRef idx="3">
+            <a:schemeClr val="lt1"/>
+          </a:lnRef>
+          <a:fillRef idx="1">
+            <a:schemeClr val="accent4"/>
+          </a:fillRef>
+          <a:effectRef idx="1">
+            <a:schemeClr val="accent4"/>
+          </a:effectRef>
+          <a:fontRef idx="minor">
+            <a:schemeClr val="lt1"/>
+          </a:fontRef>
+        </p:style>
+        <p:txBody>
+          <a:bodyPr rtlCol="0" anchor="ctr"/>
+          <a:lstStyle/>
+          <a:p>
+            <a:pPr algn="ctr"/>
+            <a:r>
+              <a:rPr lang="en-CA" dirty="0">
+                <a:solidFill>
+                  <a:schemeClr val="tx1"/>
+                </a:solidFill>
+              </a:rPr>
+              <a:t>Fragment</a:t>
+            </a:r>
+          </a:p>
+        </p:txBody>
+      </p:sp>
+      <p:sp>
+        <p:nvSpPr>
+          <p:cNvPr id="12" name="Arrow: Right 11">
+            <a:extLst>
+              <a:ext uri="{FF2B5EF4-FFF2-40B4-BE49-F238E27FC236}">
+                <a16:creationId xmlns:a16="http://schemas.microsoft.com/office/drawing/2014/main" id="{A94E4D52-A290-E5D3-0494-1F5571B038C3}"/>
+              </a:ext>
+            </a:extLst>
+          </p:cNvPr>
+          <p:cNvSpPr/>
+          <p:nvPr/>
+        </p:nvSpPr>
+        <p:spPr>
+          <a:xfrm>
+            <a:off x="11611896" y="2571136"/>
+            <a:ext cx="2261420" cy="1219200"/>
+          </a:xfrm>
+          <a:prstGeom prst="rightArrow">
+            <a:avLst/>
+          </a:prstGeom>
+        </p:spPr>
+        <p:style>
+          <a:lnRef idx="1">
+            <a:schemeClr val="accent2"/>
+          </a:lnRef>
+          <a:fillRef idx="3">
+            <a:schemeClr val="accent2"/>
+          </a:fillRef>
+          <a:effectRef idx="2">
+            <a:schemeClr val="accent2"/>
+          </a:effectRef>
+          <a:fontRef idx="minor">
+            <a:schemeClr val="lt1"/>
+          </a:fontRef>
+        </p:style>
+        <p:txBody>
+          <a:bodyPr rtlCol="0" anchor="ctr"/>
+          <a:lstStyle/>
+          <a:p>
+            <a:pPr algn="ctr"/>
+            <a:r>
+              <a:rPr lang="en-CA" dirty="0"/>
+              <a:t>To the screen (back buffer)</a:t>
+            </a:r>
+          </a:p>
+        </p:txBody>
+      </p:sp>
+      <p:sp>
+        <p:nvSpPr>
+          <p:cNvPr id="13" name="Arrow: Right 12">
+            <a:extLst>
+              <a:ext uri="{FF2B5EF4-FFF2-40B4-BE49-F238E27FC236}">
+                <a16:creationId xmlns:a16="http://schemas.microsoft.com/office/drawing/2014/main" id="{5F240329-D1AC-2AA6-9E5F-9F28FBD8DB21}"/>
+              </a:ext>
+            </a:extLst>
+          </p:cNvPr>
+          <p:cNvSpPr/>
+          <p:nvPr/>
+        </p:nvSpPr>
+        <p:spPr>
+          <a:xfrm>
+            <a:off x="7977649" y="2531806"/>
+            <a:ext cx="1565787" cy="1219200"/>
+          </a:xfrm>
+          <a:prstGeom prst="rightArrow">
+            <a:avLst/>
+          </a:prstGeom>
+        </p:spPr>
+        <p:style>
+          <a:lnRef idx="1">
+            <a:schemeClr val="accent2"/>
+          </a:lnRef>
+          <a:fillRef idx="3">
+            <a:schemeClr val="accent2"/>
+          </a:fillRef>
+          <a:effectRef idx="2">
+            <a:schemeClr val="accent2"/>
+          </a:effectRef>
+          <a:fontRef idx="minor">
+            <a:schemeClr val="lt1"/>
+          </a:fontRef>
+        </p:style>
+        <p:txBody>
+          <a:bodyPr rtlCol="0" anchor="ctr"/>
+          <a:lstStyle/>
+          <a:p>
+            <a:pPr algn="ctr"/>
+            <a:r>
+              <a:rPr lang="en-CA" dirty="0"/>
+              <a:t>VL</a:t>
+            </a:r>
+          </a:p>
+        </p:txBody>
+      </p:sp>
+      <p:sp>
+        <p:nvSpPr>
+          <p:cNvPr id="14" name="Rectangle 13">
+            <a:extLst>
+              <a:ext uri="{FF2B5EF4-FFF2-40B4-BE49-F238E27FC236}">
+                <a16:creationId xmlns:a16="http://schemas.microsoft.com/office/drawing/2014/main" id="{FEF9F6F0-10D3-CC44-912C-80D329FB5F3C}"/>
+              </a:ext>
+            </a:extLst>
+          </p:cNvPr>
+          <p:cNvSpPr/>
+          <p:nvPr/>
+        </p:nvSpPr>
+        <p:spPr>
+          <a:xfrm>
+            <a:off x="-1518476" y="1199536"/>
+            <a:ext cx="1779638" cy="3962400"/>
+          </a:xfrm>
+          <a:prstGeom prst="rect">
+            <a:avLst/>
+          </a:prstGeom>
+        </p:spPr>
+        <p:style>
+          <a:lnRef idx="3">
+            <a:schemeClr val="lt1"/>
+          </a:lnRef>
+          <a:fillRef idx="1">
+            <a:schemeClr val="accent6"/>
+          </a:fillRef>
+          <a:effectRef idx="1">
+            <a:schemeClr val="accent6"/>
+          </a:effectRef>
+          <a:fontRef idx="minor">
+            <a:schemeClr val="lt1"/>
+          </a:fontRef>
+        </p:style>
+        <p:txBody>
+          <a:bodyPr rtlCol="0" anchor="ctr"/>
+          <a:lstStyle/>
+          <a:p>
+            <a:pPr algn="ctr"/>
+            <a:r>
+              <a:rPr lang="en-CA" dirty="0"/>
+              <a:t>File</a:t>
+            </a:r>
+          </a:p>
+        </p:txBody>
+      </p:sp>
+      <p:sp>
+        <p:nvSpPr>
+          <p:cNvPr id="15" name="Arrow: Right 14">
+            <a:extLst>
+              <a:ext uri="{FF2B5EF4-FFF2-40B4-BE49-F238E27FC236}">
+                <a16:creationId xmlns:a16="http://schemas.microsoft.com/office/drawing/2014/main" id="{54854930-83AB-D2BB-035E-DDEA1FA8DE37}"/>
+              </a:ext>
+            </a:extLst>
+          </p:cNvPr>
+          <p:cNvSpPr/>
+          <p:nvPr/>
+        </p:nvSpPr>
+        <p:spPr>
+          <a:xfrm>
+            <a:off x="-69458" y="2571136"/>
+            <a:ext cx="1499418" cy="1219200"/>
+          </a:xfrm>
+          <a:prstGeom prst="rightArrow">
+            <a:avLst/>
+          </a:prstGeom>
+        </p:spPr>
+        <p:style>
+          <a:lnRef idx="1">
+            <a:schemeClr val="accent2"/>
+          </a:lnRef>
+          <a:fillRef idx="3">
+            <a:schemeClr val="accent2"/>
+          </a:fillRef>
+          <a:effectRef idx="2">
+            <a:schemeClr val="accent2"/>
+          </a:effectRef>
+          <a:fontRef idx="minor">
+            <a:schemeClr val="lt1"/>
+          </a:fontRef>
+        </p:style>
+        <p:txBody>
+          <a:bodyPr rtlCol="0" anchor="ctr"/>
+          <a:lstStyle/>
+          <a:p>
+            <a:pPr algn="ctr"/>
+            <a:endParaRPr lang="en-CA"/>
+          </a:p>
+        </p:txBody>
+      </p:sp>
+      <p:sp>
+        <p:nvSpPr>
+          <p:cNvPr id="2" name="Rectangle 1">
+            <a:extLst>
+              <a:ext uri="{FF2B5EF4-FFF2-40B4-BE49-F238E27FC236}">
+                <a16:creationId xmlns:a16="http://schemas.microsoft.com/office/drawing/2014/main" id="{8ACAC186-645C-EFF0-E5FA-8B3A73966620}"/>
+              </a:ext>
+            </a:extLst>
+          </p:cNvPr>
+          <p:cNvSpPr/>
+          <p:nvPr/>
+        </p:nvSpPr>
+        <p:spPr>
+          <a:xfrm>
+            <a:off x="6786742" y="1054509"/>
+            <a:ext cx="929146" cy="4527755"/>
+          </a:xfrm>
+          <a:prstGeom prst="rect">
+            <a:avLst/>
+          </a:prstGeom>
+        </p:spPr>
+        <p:style>
+          <a:lnRef idx="3">
+            <a:schemeClr val="lt1"/>
+          </a:lnRef>
+          <a:fillRef idx="1">
+            <a:schemeClr val="accent6"/>
+          </a:fillRef>
+          <a:effectRef idx="1">
+            <a:schemeClr val="accent6"/>
+          </a:effectRef>
+          <a:fontRef idx="minor">
+            <a:schemeClr val="lt1"/>
+          </a:fontRef>
+        </p:style>
+        <p:txBody>
+          <a:bodyPr rtlCol="0" anchor="ctr"/>
+          <a:lstStyle/>
+          <a:p>
+            <a:pPr algn="ctr"/>
+            <a:r>
+              <a:rPr lang="en-CA" dirty="0"/>
+              <a:t>Vertex</a:t>
+            </a:r>
+          </a:p>
+          <a:p>
+            <a:pPr algn="ctr"/>
+            <a:r>
+              <a:rPr lang="en-CA" dirty="0"/>
+              <a:t>buffer</a:t>
+            </a:r>
+          </a:p>
+        </p:txBody>
+      </p:sp>
+      <p:sp>
+        <p:nvSpPr>
+          <p:cNvPr id="16" name="Rectangle 15">
+            <a:extLst>
+              <a:ext uri="{FF2B5EF4-FFF2-40B4-BE49-F238E27FC236}">
+                <a16:creationId xmlns:a16="http://schemas.microsoft.com/office/drawing/2014/main" id="{6B32005D-24B1-6C8F-15DD-E7576D9A8BF6}"/>
+              </a:ext>
+            </a:extLst>
+          </p:cNvPr>
+          <p:cNvSpPr/>
+          <p:nvPr/>
+        </p:nvSpPr>
+        <p:spPr>
+          <a:xfrm>
+            <a:off x="1535415" y="3620731"/>
+            <a:ext cx="1031434" cy="2005780"/>
+          </a:xfrm>
+          <a:prstGeom prst="rect">
+            <a:avLst/>
+          </a:prstGeom>
+        </p:spPr>
+        <p:style>
+          <a:lnRef idx="0">
+            <a:schemeClr val="accent4"/>
+          </a:lnRef>
+          <a:fillRef idx="3">
+            <a:schemeClr val="accent4"/>
+          </a:fillRef>
+          <a:effectRef idx="3">
+            <a:schemeClr val="accent4"/>
+          </a:effectRef>
+          <a:fontRef idx="minor">
+            <a:schemeClr val="lt1"/>
+          </a:fontRef>
+        </p:style>
+        <p:txBody>
+          <a:bodyPr rtlCol="0" anchor="ctr"/>
+          <a:lstStyle/>
+          <a:p>
+            <a:pPr algn="ctr"/>
+            <a:r>
+              <a:rPr lang="en-CA" dirty="0"/>
+              <a:t>Faces</a:t>
+            </a:r>
+          </a:p>
+        </p:txBody>
+      </p:sp>
+      <p:sp>
+        <p:nvSpPr>
+          <p:cNvPr id="17" name="Rectangle 16">
+            <a:extLst>
+              <a:ext uri="{FF2B5EF4-FFF2-40B4-BE49-F238E27FC236}">
+                <a16:creationId xmlns:a16="http://schemas.microsoft.com/office/drawing/2014/main" id="{4B950A47-E556-1D38-9983-6481AA81609C}"/>
+              </a:ext>
+            </a:extLst>
+          </p:cNvPr>
+          <p:cNvSpPr/>
+          <p:nvPr/>
+        </p:nvSpPr>
+        <p:spPr>
+          <a:xfrm>
+            <a:off x="3219930" y="1423219"/>
+            <a:ext cx="1031434" cy="4299155"/>
+          </a:xfrm>
+          <a:prstGeom prst="rect">
+            <a:avLst/>
+          </a:prstGeom>
+        </p:spPr>
+        <p:style>
+          <a:lnRef idx="3">
+            <a:schemeClr val="lt1"/>
+          </a:lnRef>
+          <a:fillRef idx="1">
+            <a:schemeClr val="accent6"/>
+          </a:fillRef>
+          <a:effectRef idx="1">
+            <a:schemeClr val="accent6"/>
+          </a:effectRef>
+          <a:fontRef idx="minor">
+            <a:schemeClr val="lt1"/>
+          </a:fontRef>
+        </p:style>
+        <p:txBody>
+          <a:bodyPr rtlCol="0" anchor="ctr"/>
+          <a:lstStyle/>
+          <a:p>
+            <a:pPr algn="ctr"/>
+            <a:r>
+              <a:rPr lang="en-CA" dirty="0"/>
+              <a:t>Vertices</a:t>
+            </a:r>
+          </a:p>
+        </p:txBody>
+      </p:sp>
+      <p:sp>
+        <p:nvSpPr>
+          <p:cNvPr id="18" name="Arrow: Right 17">
+            <a:extLst>
+              <a:ext uri="{FF2B5EF4-FFF2-40B4-BE49-F238E27FC236}">
+                <a16:creationId xmlns:a16="http://schemas.microsoft.com/office/drawing/2014/main" id="{E8CD2C7A-17C4-5CF2-4D6E-63AB3CB87B7B}"/>
+              </a:ext>
+            </a:extLst>
+          </p:cNvPr>
+          <p:cNvSpPr/>
+          <p:nvPr/>
+        </p:nvSpPr>
+        <p:spPr>
+          <a:xfrm>
+            <a:off x="2450346" y="2819399"/>
+            <a:ext cx="1176901" cy="1219200"/>
+          </a:xfrm>
+          <a:prstGeom prst="rightArrow">
+            <a:avLst/>
+          </a:prstGeom>
+        </p:spPr>
+        <p:style>
+          <a:lnRef idx="1">
+            <a:schemeClr val="accent2"/>
+          </a:lnRef>
+          <a:fillRef idx="3">
+            <a:schemeClr val="accent2"/>
+          </a:fillRef>
+          <a:effectRef idx="2">
+            <a:schemeClr val="accent2"/>
+          </a:effectRef>
+          <a:fontRef idx="minor">
+            <a:schemeClr val="lt1"/>
+          </a:fontRef>
+        </p:style>
+        <p:txBody>
+          <a:bodyPr rtlCol="0" anchor="ctr"/>
+          <a:lstStyle/>
+          <a:p>
+            <a:pPr algn="ctr"/>
+            <a:endParaRPr lang="en-CA"/>
+          </a:p>
+        </p:txBody>
+      </p:sp>
+    </p:spTree>
+    <p:extLst>
+      <p:ext uri="{BB962C8B-B14F-4D97-AF65-F5344CB8AC3E}">
+        <p14:creationId xmlns:p14="http://schemas.microsoft.com/office/powerpoint/2010/main" val="862024024"/>
+      </p:ext>
+    </p:extLst>
+  </p:cSld>
+  <p:clrMapOvr>
+    <a:masterClrMapping/>
+  </p:clrMapOvr>
+</p:sld>
+</file>
+
+<file path=ppt/slides/slide4.xml><?xml version="1.0" encoding="utf-8"?>
+<p:sld xmlns:a="http://schemas.openxmlformats.org/drawingml/2006/main" xmlns:r="http://schemas.openxmlformats.org/officeDocument/2006/relationships" xmlns:p="http://schemas.openxmlformats.org/presentationml/2006/main">
+  <p:cSld>
+    <p:spTree>
+      <p:nvGrpSpPr>
+        <p:cNvPr id="1" name=""/>
+        <p:cNvGrpSpPr/>
+        <p:nvPr/>
+      </p:nvGrpSpPr>
+      <p:grpSpPr>
+        <a:xfrm>
+          <a:off x="0" y="0"/>
+          <a:ext cx="0" cy="0"/>
+          <a:chOff x="0" y="0"/>
+          <a:chExt cx="0" cy="0"/>
+        </a:xfrm>
+      </p:grpSpPr>
+      <p:sp>
+        <p:nvSpPr>
+          <p:cNvPr id="5" name="Rectangle: Rounded Corners 4">
+            <a:extLst>
+              <a:ext uri="{FF2B5EF4-FFF2-40B4-BE49-F238E27FC236}">
+                <a16:creationId xmlns:a16="http://schemas.microsoft.com/office/drawing/2014/main" id="{855FD758-8CA8-97F0-86A6-673795C8D55E}"/>
+              </a:ext>
+            </a:extLst>
+          </p:cNvPr>
+          <p:cNvSpPr/>
+          <p:nvPr/>
+        </p:nvSpPr>
+        <p:spPr>
+          <a:xfrm>
+            <a:off x="1292596" y="88490"/>
+            <a:ext cx="3476050" cy="6459794"/>
+          </a:xfrm>
+          <a:prstGeom prst="roundRect">
+            <a:avLst/>
+          </a:prstGeom>
+        </p:spPr>
+        <p:style>
+          <a:lnRef idx="2">
+            <a:schemeClr val="accent1">
+              <a:shade val="15000"/>
+            </a:schemeClr>
+          </a:lnRef>
+          <a:fillRef idx="1">
+            <a:schemeClr val="accent1"/>
+          </a:fillRef>
+          <a:effectRef idx="0">
+            <a:schemeClr val="accent1"/>
+          </a:effectRef>
+          <a:fontRef idx="minor">
+            <a:schemeClr val="lt1"/>
+          </a:fontRef>
+        </p:style>
+        <p:txBody>
+          <a:bodyPr rtlCol="0" anchor="ctr"/>
+          <a:lstStyle/>
+          <a:p>
+            <a:pPr algn="ctr"/>
+            <a:r>
+              <a:rPr lang="en-CA" dirty="0"/>
+              <a:t>CPU (C++)</a:t>
+            </a:r>
+          </a:p>
+          <a:p>
+            <a:pPr algn="ctr"/>
+            <a:endParaRPr lang="en-CA" dirty="0"/>
+          </a:p>
+          <a:p>
+            <a:pPr algn="ctr"/>
+            <a:endParaRPr lang="en-CA" dirty="0"/>
+          </a:p>
+          <a:p>
+            <a:pPr algn="ctr"/>
+            <a:endParaRPr lang="en-CA" dirty="0"/>
+          </a:p>
+          <a:p>
+            <a:pPr algn="ctr"/>
+            <a:endParaRPr lang="en-CA" dirty="0"/>
+          </a:p>
+          <a:p>
+            <a:pPr algn="ctr"/>
+            <a:endParaRPr lang="en-CA" dirty="0"/>
+          </a:p>
+          <a:p>
+            <a:pPr algn="ctr"/>
+            <a:endParaRPr lang="en-CA" dirty="0"/>
+          </a:p>
+          <a:p>
+            <a:pPr algn="ctr"/>
+            <a:endParaRPr lang="en-CA" dirty="0"/>
+          </a:p>
+          <a:p>
+            <a:pPr algn="ctr"/>
+            <a:endParaRPr lang="en-CA" dirty="0"/>
+          </a:p>
+          <a:p>
+            <a:pPr algn="ctr"/>
+            <a:endParaRPr lang="en-CA" dirty="0"/>
+          </a:p>
+          <a:p>
+            <a:pPr algn="ctr"/>
+            <a:endParaRPr lang="en-CA" dirty="0"/>
+          </a:p>
+          <a:p>
+            <a:pPr algn="ctr"/>
+            <a:endParaRPr lang="en-CA" dirty="0"/>
+          </a:p>
+          <a:p>
+            <a:pPr algn="ctr"/>
+            <a:endParaRPr lang="en-CA" dirty="0"/>
+          </a:p>
+          <a:p>
+            <a:pPr algn="ctr"/>
+            <a:endParaRPr lang="en-CA" dirty="0"/>
+          </a:p>
+          <a:p>
+            <a:pPr algn="ctr"/>
+            <a:endParaRPr lang="en-CA" dirty="0"/>
+          </a:p>
+          <a:p>
+            <a:pPr algn="ctr"/>
+            <a:endParaRPr lang="en-CA" dirty="0"/>
+          </a:p>
+          <a:p>
+            <a:pPr algn="ctr"/>
+            <a:endParaRPr lang="en-CA" dirty="0"/>
+          </a:p>
+          <a:p>
+            <a:pPr algn="ctr"/>
+            <a:r>
+              <a:rPr lang="en-CA" dirty="0"/>
+              <a:t> </a:t>
+            </a:r>
+          </a:p>
+        </p:txBody>
+      </p:sp>
+      <p:sp>
+        <p:nvSpPr>
+          <p:cNvPr id="4" name="Rectangle 3">
+            <a:extLst>
+              <a:ext uri="{FF2B5EF4-FFF2-40B4-BE49-F238E27FC236}">
+                <a16:creationId xmlns:a16="http://schemas.microsoft.com/office/drawing/2014/main" id="{9A6E1664-BDE9-C8D9-CFE3-3745CB0CEEB5}"/>
+              </a:ext>
+            </a:extLst>
+          </p:cNvPr>
+          <p:cNvSpPr/>
+          <p:nvPr/>
+        </p:nvSpPr>
+        <p:spPr>
+          <a:xfrm>
+            <a:off x="2132847" y="1370899"/>
+            <a:ext cx="1031434" cy="2005780"/>
+          </a:xfrm>
+          <a:prstGeom prst="rect">
+            <a:avLst/>
+          </a:prstGeom>
+        </p:spPr>
+        <p:style>
+          <a:lnRef idx="0">
+            <a:schemeClr val="accent4"/>
+          </a:lnRef>
+          <a:fillRef idx="3">
+            <a:schemeClr val="accent4"/>
+          </a:fillRef>
+          <a:effectRef idx="3">
+            <a:schemeClr val="accent4"/>
+          </a:effectRef>
+          <a:fontRef idx="minor">
+            <a:schemeClr val="lt1"/>
+          </a:fontRef>
+        </p:style>
+        <p:txBody>
+          <a:bodyPr rtlCol="0" anchor="ctr"/>
+          <a:lstStyle/>
+          <a:p>
+            <a:pPr algn="ctr"/>
+            <a:r>
+              <a:rPr lang="en-CA" dirty="0"/>
+              <a:t>Vertices</a:t>
+            </a:r>
+          </a:p>
+        </p:txBody>
+      </p:sp>
+      <p:sp>
+        <p:nvSpPr>
+          <p:cNvPr id="6" name="Rectangle: Rounded Corners 5">
+            <a:extLst>
+              <a:ext uri="{FF2B5EF4-FFF2-40B4-BE49-F238E27FC236}">
+                <a16:creationId xmlns:a16="http://schemas.microsoft.com/office/drawing/2014/main" id="{A7AB6A8E-617B-EFE7-82EB-41E6C14BB692}"/>
+              </a:ext>
+            </a:extLst>
+          </p:cNvPr>
+          <p:cNvSpPr/>
+          <p:nvPr/>
+        </p:nvSpPr>
+        <p:spPr>
+          <a:xfrm>
+            <a:off x="5830530" y="88490"/>
+            <a:ext cx="5309418" cy="6459794"/>
+          </a:xfrm>
+          <a:prstGeom prst="roundRect">
+            <a:avLst/>
+          </a:prstGeom>
+        </p:spPr>
+        <p:style>
+          <a:lnRef idx="2">
+            <a:schemeClr val="accent1">
+              <a:shade val="15000"/>
+            </a:schemeClr>
+          </a:lnRef>
+          <a:fillRef idx="1">
+            <a:schemeClr val="accent1"/>
+          </a:fillRef>
+          <a:effectRef idx="0">
+            <a:schemeClr val="accent1"/>
+          </a:effectRef>
+          <a:fontRef idx="minor">
+            <a:schemeClr val="lt1"/>
+          </a:fontRef>
+        </p:style>
+        <p:txBody>
+          <a:bodyPr rtlCol="0" anchor="ctr"/>
+          <a:lstStyle/>
+          <a:p>
+            <a:pPr algn="ctr"/>
+            <a:r>
+              <a:rPr lang="en-CA" dirty="0"/>
+              <a:t>GPU</a:t>
+            </a:r>
+          </a:p>
+          <a:p>
+            <a:pPr algn="ctr"/>
+            <a:endParaRPr lang="en-CA" dirty="0"/>
+          </a:p>
+          <a:p>
+            <a:pPr algn="ctr"/>
+            <a:endParaRPr lang="en-CA" dirty="0"/>
+          </a:p>
+          <a:p>
+            <a:pPr algn="ctr"/>
+            <a:endParaRPr lang="en-CA" dirty="0"/>
+          </a:p>
+          <a:p>
+            <a:pPr algn="ctr"/>
+            <a:endParaRPr lang="en-CA" dirty="0"/>
+          </a:p>
+          <a:p>
+            <a:pPr algn="ctr"/>
+            <a:endParaRPr lang="en-CA" dirty="0"/>
+          </a:p>
+          <a:p>
+            <a:pPr algn="ctr"/>
+            <a:endParaRPr lang="en-CA" dirty="0"/>
+          </a:p>
+          <a:p>
+            <a:pPr algn="ctr"/>
+            <a:endParaRPr lang="en-CA" dirty="0"/>
+          </a:p>
+          <a:p>
+            <a:pPr algn="ctr"/>
+            <a:endParaRPr lang="en-CA" dirty="0"/>
+          </a:p>
+          <a:p>
+            <a:pPr algn="ctr"/>
+            <a:endParaRPr lang="en-CA" dirty="0"/>
+          </a:p>
+          <a:p>
+            <a:pPr algn="ctr"/>
+            <a:endParaRPr lang="en-CA" dirty="0"/>
+          </a:p>
+          <a:p>
+            <a:pPr algn="ctr"/>
+            <a:endParaRPr lang="en-CA" dirty="0"/>
+          </a:p>
+          <a:p>
+            <a:pPr algn="ctr"/>
+            <a:endParaRPr lang="en-CA" dirty="0"/>
+          </a:p>
+          <a:p>
+            <a:pPr algn="ctr"/>
+            <a:endParaRPr lang="en-CA" dirty="0"/>
+          </a:p>
+          <a:p>
+            <a:pPr algn="ctr"/>
+            <a:endParaRPr lang="en-CA" dirty="0"/>
+          </a:p>
+          <a:p>
+            <a:pPr algn="ctr"/>
+            <a:endParaRPr lang="en-CA" dirty="0"/>
+          </a:p>
+          <a:p>
+            <a:pPr algn="ctr"/>
+            <a:endParaRPr lang="en-CA" dirty="0"/>
+          </a:p>
+          <a:p>
+            <a:pPr algn="ctr"/>
+            <a:endParaRPr lang="en-CA" dirty="0"/>
+          </a:p>
+        </p:txBody>
+      </p:sp>
+      <p:sp>
+        <p:nvSpPr>
+          <p:cNvPr id="8" name="Arrow: Right 7">
+            <a:extLst>
+              <a:ext uri="{FF2B5EF4-FFF2-40B4-BE49-F238E27FC236}">
+                <a16:creationId xmlns:a16="http://schemas.microsoft.com/office/drawing/2014/main" id="{9E9D5935-7A52-C77B-8374-E864BCEE7462}"/>
+              </a:ext>
+            </a:extLst>
+          </p:cNvPr>
+          <p:cNvSpPr/>
+          <p:nvPr/>
+        </p:nvSpPr>
+        <p:spPr>
+          <a:xfrm>
+            <a:off x="3164282" y="2767079"/>
+            <a:ext cx="3360700" cy="1219200"/>
+          </a:xfrm>
+          <a:prstGeom prst="rightArrow">
+            <a:avLst/>
+          </a:prstGeom>
+        </p:spPr>
+        <p:style>
+          <a:lnRef idx="1">
+            <a:schemeClr val="accent2"/>
+          </a:lnRef>
+          <a:fillRef idx="3">
+            <a:schemeClr val="accent2"/>
+          </a:fillRef>
+          <a:effectRef idx="2">
+            <a:schemeClr val="accent2"/>
+          </a:effectRef>
+          <a:fontRef idx="minor">
+            <a:schemeClr val="lt1"/>
+          </a:fontRef>
+        </p:style>
+        <p:txBody>
+          <a:bodyPr rtlCol="0" anchor="ctr"/>
+          <a:lstStyle/>
+          <a:p>
+            <a:pPr algn="ctr"/>
+            <a:endParaRPr lang="en-CA"/>
+          </a:p>
+        </p:txBody>
+      </p:sp>
+      <p:sp>
+        <p:nvSpPr>
+          <p:cNvPr id="11" name="Rectangle: Rounded Corners 10">
+            <a:extLst>
+              <a:ext uri="{FF2B5EF4-FFF2-40B4-BE49-F238E27FC236}">
+                <a16:creationId xmlns:a16="http://schemas.microsoft.com/office/drawing/2014/main" id="{DD8208FC-83C2-3DB4-987C-E51904197546}"/>
+              </a:ext>
+            </a:extLst>
+          </p:cNvPr>
+          <p:cNvSpPr/>
+          <p:nvPr/>
+        </p:nvSpPr>
+        <p:spPr>
+          <a:xfrm>
+            <a:off x="8554065" y="1622323"/>
+            <a:ext cx="2792361" cy="2969343"/>
+          </a:xfrm>
+          <a:prstGeom prst="roundRect">
+            <a:avLst/>
+          </a:prstGeom>
+        </p:spPr>
+        <p:style>
+          <a:lnRef idx="2">
+            <a:schemeClr val="accent1">
+              <a:shade val="15000"/>
+            </a:schemeClr>
+          </a:lnRef>
+          <a:fillRef idx="1">
+            <a:schemeClr val="accent1"/>
+          </a:fillRef>
+          <a:effectRef idx="0">
+            <a:schemeClr val="accent1"/>
+          </a:effectRef>
+          <a:fontRef idx="minor">
+            <a:schemeClr val="lt1"/>
+          </a:fontRef>
+        </p:style>
+        <p:txBody>
+          <a:bodyPr rtlCol="0" anchor="ctr"/>
+          <a:lstStyle/>
+          <a:p>
+            <a:pPr algn="ctr"/>
+            <a:r>
+              <a:rPr lang="en-CA" dirty="0"/>
+              <a:t>Shader “Program”</a:t>
+            </a:r>
+          </a:p>
+          <a:p>
+            <a:pPr algn="ctr"/>
+            <a:endParaRPr lang="en-CA" dirty="0"/>
+          </a:p>
+          <a:p>
+            <a:pPr algn="ctr"/>
+            <a:endParaRPr lang="en-CA" dirty="0"/>
+          </a:p>
+          <a:p>
+            <a:pPr algn="ctr"/>
+            <a:endParaRPr lang="en-CA" dirty="0"/>
+          </a:p>
+          <a:p>
+            <a:pPr algn="ctr"/>
+            <a:endParaRPr lang="en-CA" dirty="0"/>
+          </a:p>
+          <a:p>
+            <a:pPr algn="ctr"/>
+            <a:endParaRPr lang="en-CA" dirty="0"/>
+          </a:p>
+          <a:p>
+            <a:pPr algn="ctr"/>
+            <a:endParaRPr lang="en-CA" dirty="0"/>
+          </a:p>
+          <a:p>
+            <a:pPr algn="ctr"/>
+            <a:endParaRPr lang="en-CA" dirty="0"/>
+          </a:p>
+          <a:p>
+            <a:pPr algn="ctr"/>
+            <a:endParaRPr lang="en-CA" dirty="0"/>
+          </a:p>
+          <a:p>
+            <a:pPr algn="ctr"/>
+            <a:endParaRPr lang="en-CA" dirty="0"/>
+          </a:p>
+        </p:txBody>
+      </p:sp>
+      <p:sp>
+        <p:nvSpPr>
+          <p:cNvPr id="9" name="Rectangle: Rounded Corners 8">
+            <a:extLst>
+              <a:ext uri="{FF2B5EF4-FFF2-40B4-BE49-F238E27FC236}">
+                <a16:creationId xmlns:a16="http://schemas.microsoft.com/office/drawing/2014/main" id="{C770166A-DA62-5E5D-EC57-615034048C5E}"/>
+              </a:ext>
+            </a:extLst>
+          </p:cNvPr>
+          <p:cNvSpPr/>
+          <p:nvPr/>
+        </p:nvSpPr>
+        <p:spPr>
+          <a:xfrm>
+            <a:off x="9026013" y="2271253"/>
+            <a:ext cx="1986116" cy="835742"/>
+          </a:xfrm>
+          <a:prstGeom prst="roundRect">
+            <a:avLst/>
+          </a:prstGeom>
+        </p:spPr>
+        <p:style>
+          <a:lnRef idx="3">
+            <a:schemeClr val="lt1"/>
+          </a:lnRef>
+          <a:fillRef idx="1">
+            <a:schemeClr val="accent4"/>
+          </a:fillRef>
+          <a:effectRef idx="1">
+            <a:schemeClr val="accent4"/>
+          </a:effectRef>
+          <a:fontRef idx="minor">
+            <a:schemeClr val="lt1"/>
+          </a:fontRef>
+        </p:style>
+        <p:txBody>
+          <a:bodyPr rtlCol="0" anchor="ctr"/>
+          <a:lstStyle/>
+          <a:p>
+            <a:pPr algn="ctr"/>
+            <a:r>
+              <a:rPr lang="en-CA" dirty="0">
+                <a:solidFill>
+                  <a:schemeClr val="tx1"/>
+                </a:solidFill>
+              </a:rPr>
+              <a:t>Vertex</a:t>
+            </a:r>
+          </a:p>
+        </p:txBody>
+      </p:sp>
+      <p:sp>
+        <p:nvSpPr>
+          <p:cNvPr id="10" name="Rectangle: Rounded Corners 9">
+            <a:extLst>
+              <a:ext uri="{FF2B5EF4-FFF2-40B4-BE49-F238E27FC236}">
+                <a16:creationId xmlns:a16="http://schemas.microsoft.com/office/drawing/2014/main" id="{F55A8CC1-47C2-1E03-2710-00949FBA61EF}"/>
+              </a:ext>
+            </a:extLst>
+          </p:cNvPr>
+          <p:cNvSpPr/>
+          <p:nvPr/>
+        </p:nvSpPr>
+        <p:spPr>
+          <a:xfrm>
+            <a:off x="9026013" y="3298724"/>
+            <a:ext cx="1986116" cy="835742"/>
+          </a:xfrm>
+          <a:prstGeom prst="roundRect">
+            <a:avLst/>
+          </a:prstGeom>
+        </p:spPr>
+        <p:style>
+          <a:lnRef idx="3">
+            <a:schemeClr val="lt1"/>
+          </a:lnRef>
+          <a:fillRef idx="1">
+            <a:schemeClr val="accent4"/>
+          </a:fillRef>
+          <a:effectRef idx="1">
+            <a:schemeClr val="accent4"/>
+          </a:effectRef>
+          <a:fontRef idx="minor">
+            <a:schemeClr val="lt1"/>
+          </a:fontRef>
+        </p:style>
+        <p:txBody>
+          <a:bodyPr rtlCol="0" anchor="ctr"/>
+          <a:lstStyle/>
+          <a:p>
+            <a:pPr algn="ctr"/>
+            <a:r>
+              <a:rPr lang="en-CA" dirty="0">
+                <a:solidFill>
+                  <a:schemeClr val="tx1"/>
+                </a:solidFill>
+              </a:rPr>
+              <a:t>Fragment</a:t>
+            </a:r>
+          </a:p>
+        </p:txBody>
+      </p:sp>
+      <p:sp>
+        <p:nvSpPr>
+          <p:cNvPr id="12" name="Arrow: Right 11">
+            <a:extLst>
+              <a:ext uri="{FF2B5EF4-FFF2-40B4-BE49-F238E27FC236}">
+                <a16:creationId xmlns:a16="http://schemas.microsoft.com/office/drawing/2014/main" id="{A94E4D52-A290-E5D3-0494-1F5571B038C3}"/>
+              </a:ext>
+            </a:extLst>
+          </p:cNvPr>
+          <p:cNvSpPr/>
+          <p:nvPr/>
+        </p:nvSpPr>
+        <p:spPr>
+          <a:xfrm>
+            <a:off x="11611896" y="2571136"/>
+            <a:ext cx="2261420" cy="1219200"/>
+          </a:xfrm>
+          <a:prstGeom prst="rightArrow">
+            <a:avLst/>
+          </a:prstGeom>
+        </p:spPr>
+        <p:style>
+          <a:lnRef idx="1">
+            <a:schemeClr val="accent2"/>
+          </a:lnRef>
+          <a:fillRef idx="3">
+            <a:schemeClr val="accent2"/>
+          </a:fillRef>
+          <a:effectRef idx="2">
+            <a:schemeClr val="accent2"/>
+          </a:effectRef>
+          <a:fontRef idx="minor">
+            <a:schemeClr val="lt1"/>
+          </a:fontRef>
+        </p:style>
+        <p:txBody>
+          <a:bodyPr rtlCol="0" anchor="ctr"/>
+          <a:lstStyle/>
+          <a:p>
+            <a:pPr algn="ctr"/>
+            <a:r>
+              <a:rPr lang="en-CA" dirty="0"/>
+              <a:t>To the screen (back buffer)</a:t>
+            </a:r>
+          </a:p>
+        </p:txBody>
+      </p:sp>
+      <p:sp>
+        <p:nvSpPr>
+          <p:cNvPr id="13" name="Arrow: Right 12">
+            <a:extLst>
+              <a:ext uri="{FF2B5EF4-FFF2-40B4-BE49-F238E27FC236}">
+                <a16:creationId xmlns:a16="http://schemas.microsoft.com/office/drawing/2014/main" id="{5F240329-D1AC-2AA6-9E5F-9F28FBD8DB21}"/>
+              </a:ext>
+            </a:extLst>
+          </p:cNvPr>
+          <p:cNvSpPr/>
+          <p:nvPr/>
+        </p:nvSpPr>
+        <p:spPr>
+          <a:xfrm>
+            <a:off x="7977649" y="2531806"/>
+            <a:ext cx="1565787" cy="1219200"/>
+          </a:xfrm>
+          <a:prstGeom prst="rightArrow">
+            <a:avLst/>
+          </a:prstGeom>
+        </p:spPr>
+        <p:style>
+          <a:lnRef idx="1">
+            <a:schemeClr val="accent2"/>
+          </a:lnRef>
+          <a:fillRef idx="3">
+            <a:schemeClr val="accent2"/>
+          </a:fillRef>
+          <a:effectRef idx="2">
+            <a:schemeClr val="accent2"/>
+          </a:effectRef>
+          <a:fontRef idx="minor">
+            <a:schemeClr val="lt1"/>
+          </a:fontRef>
+        </p:style>
+        <p:txBody>
+          <a:bodyPr rtlCol="0" anchor="ctr"/>
+          <a:lstStyle/>
+          <a:p>
+            <a:pPr algn="ctr"/>
+            <a:r>
+              <a:rPr lang="en-CA" dirty="0"/>
+              <a:t>VL</a:t>
+            </a:r>
+          </a:p>
+        </p:txBody>
+      </p:sp>
+      <p:sp>
+        <p:nvSpPr>
+          <p:cNvPr id="14" name="Rectangle 13">
+            <a:extLst>
+              <a:ext uri="{FF2B5EF4-FFF2-40B4-BE49-F238E27FC236}">
+                <a16:creationId xmlns:a16="http://schemas.microsoft.com/office/drawing/2014/main" id="{FEF9F6F0-10D3-CC44-912C-80D329FB5F3C}"/>
+              </a:ext>
+            </a:extLst>
+          </p:cNvPr>
+          <p:cNvSpPr/>
+          <p:nvPr/>
+        </p:nvSpPr>
+        <p:spPr>
+          <a:xfrm>
+            <a:off x="-1518476" y="1199536"/>
+            <a:ext cx="1779638" cy="3962400"/>
+          </a:xfrm>
+          <a:prstGeom prst="rect">
+            <a:avLst/>
+          </a:prstGeom>
+        </p:spPr>
+        <p:style>
+          <a:lnRef idx="3">
+            <a:schemeClr val="lt1"/>
+          </a:lnRef>
+          <a:fillRef idx="1">
+            <a:schemeClr val="accent6"/>
+          </a:fillRef>
+          <a:effectRef idx="1">
+            <a:schemeClr val="accent6"/>
+          </a:effectRef>
+          <a:fontRef idx="minor">
+            <a:schemeClr val="lt1"/>
+          </a:fontRef>
+        </p:style>
+        <p:txBody>
+          <a:bodyPr rtlCol="0" anchor="ctr"/>
+          <a:lstStyle/>
+          <a:p>
+            <a:pPr algn="ctr"/>
+            <a:r>
+              <a:rPr lang="en-CA" dirty="0"/>
+              <a:t>File</a:t>
+            </a:r>
+          </a:p>
+        </p:txBody>
+      </p:sp>
+      <p:sp>
+        <p:nvSpPr>
+          <p:cNvPr id="15" name="Arrow: Right 14">
+            <a:extLst>
+              <a:ext uri="{FF2B5EF4-FFF2-40B4-BE49-F238E27FC236}">
+                <a16:creationId xmlns:a16="http://schemas.microsoft.com/office/drawing/2014/main" id="{54854930-83AB-D2BB-035E-DDEA1FA8DE37}"/>
+              </a:ext>
+            </a:extLst>
+          </p:cNvPr>
+          <p:cNvSpPr/>
+          <p:nvPr/>
+        </p:nvSpPr>
+        <p:spPr>
+          <a:xfrm>
+            <a:off x="-69458" y="2571136"/>
+            <a:ext cx="1499418" cy="1219200"/>
+          </a:xfrm>
+          <a:prstGeom prst="rightArrow">
+            <a:avLst/>
+          </a:prstGeom>
+        </p:spPr>
+        <p:style>
+          <a:lnRef idx="1">
+            <a:schemeClr val="accent2"/>
+          </a:lnRef>
+          <a:fillRef idx="3">
+            <a:schemeClr val="accent2"/>
+          </a:fillRef>
+          <a:effectRef idx="2">
+            <a:schemeClr val="accent2"/>
+          </a:effectRef>
+          <a:fontRef idx="minor">
+            <a:schemeClr val="lt1"/>
+          </a:fontRef>
+        </p:style>
+        <p:txBody>
+          <a:bodyPr rtlCol="0" anchor="ctr"/>
+          <a:lstStyle/>
+          <a:p>
+            <a:pPr algn="ctr"/>
+            <a:endParaRPr lang="en-CA"/>
+          </a:p>
+        </p:txBody>
+      </p:sp>
+      <p:sp>
+        <p:nvSpPr>
+          <p:cNvPr id="2" name="Rectangle 1">
+            <a:extLst>
+              <a:ext uri="{FF2B5EF4-FFF2-40B4-BE49-F238E27FC236}">
+                <a16:creationId xmlns:a16="http://schemas.microsoft.com/office/drawing/2014/main" id="{8ACAC186-645C-EFF0-E5FA-8B3A73966620}"/>
+              </a:ext>
+            </a:extLst>
+          </p:cNvPr>
+          <p:cNvSpPr/>
+          <p:nvPr/>
+        </p:nvSpPr>
+        <p:spPr>
+          <a:xfrm>
+            <a:off x="6627560" y="1054506"/>
+            <a:ext cx="929146" cy="2244215"/>
+          </a:xfrm>
+          <a:prstGeom prst="rect">
+            <a:avLst/>
+          </a:prstGeom>
+        </p:spPr>
+        <p:style>
+          <a:lnRef idx="3">
+            <a:schemeClr val="lt1"/>
+          </a:lnRef>
+          <a:fillRef idx="1">
+            <a:schemeClr val="accent6"/>
+          </a:fillRef>
+          <a:effectRef idx="1">
+            <a:schemeClr val="accent6"/>
+          </a:effectRef>
+          <a:fontRef idx="minor">
+            <a:schemeClr val="lt1"/>
+          </a:fontRef>
+        </p:style>
+        <p:txBody>
+          <a:bodyPr rtlCol="0" anchor="ctr"/>
+          <a:lstStyle/>
+          <a:p>
+            <a:pPr algn="ctr"/>
+            <a:r>
+              <a:rPr lang="en-CA" dirty="0"/>
+              <a:t>Vertex</a:t>
+            </a:r>
+          </a:p>
+          <a:p>
+            <a:pPr algn="ctr"/>
+            <a:r>
+              <a:rPr lang="en-CA" dirty="0"/>
+              <a:t>buffer</a:t>
+            </a:r>
+          </a:p>
+        </p:txBody>
+      </p:sp>
+      <p:sp>
+        <p:nvSpPr>
+          <p:cNvPr id="16" name="Rectangle 15">
+            <a:extLst>
+              <a:ext uri="{FF2B5EF4-FFF2-40B4-BE49-F238E27FC236}">
+                <a16:creationId xmlns:a16="http://schemas.microsoft.com/office/drawing/2014/main" id="{6B32005D-24B1-6C8F-15DD-E7576D9A8BF6}"/>
+              </a:ext>
+            </a:extLst>
+          </p:cNvPr>
+          <p:cNvSpPr/>
+          <p:nvPr/>
+        </p:nvSpPr>
+        <p:spPr>
+          <a:xfrm>
+            <a:off x="2132847" y="3654791"/>
+            <a:ext cx="1031434" cy="2005780"/>
+          </a:xfrm>
+          <a:prstGeom prst="rect">
+            <a:avLst/>
+          </a:prstGeom>
+        </p:spPr>
+        <p:style>
+          <a:lnRef idx="0">
+            <a:schemeClr val="accent4"/>
+          </a:lnRef>
+          <a:fillRef idx="3">
+            <a:schemeClr val="accent4"/>
+          </a:fillRef>
+          <a:effectRef idx="3">
+            <a:schemeClr val="accent4"/>
+          </a:effectRef>
+          <a:fontRef idx="minor">
+            <a:schemeClr val="lt1"/>
+          </a:fontRef>
+        </p:style>
+        <p:txBody>
+          <a:bodyPr rtlCol="0" anchor="ctr"/>
+          <a:lstStyle/>
+          <a:p>
+            <a:pPr algn="ctr"/>
+            <a:r>
+              <a:rPr lang="en-CA" dirty="0"/>
+              <a:t>Faces</a:t>
+            </a:r>
+          </a:p>
+        </p:txBody>
+      </p:sp>
+      <p:sp>
+        <p:nvSpPr>
+          <p:cNvPr id="3" name="Rectangle 2">
+            <a:extLst>
+              <a:ext uri="{FF2B5EF4-FFF2-40B4-BE49-F238E27FC236}">
+                <a16:creationId xmlns:a16="http://schemas.microsoft.com/office/drawing/2014/main" id="{6A634C9A-65D5-0306-D210-F6B46E358E37}"/>
+              </a:ext>
+            </a:extLst>
+          </p:cNvPr>
+          <p:cNvSpPr/>
+          <p:nvPr/>
+        </p:nvSpPr>
+        <p:spPr>
+          <a:xfrm>
+            <a:off x="6658007" y="3588776"/>
+            <a:ext cx="1031434" cy="2005780"/>
+          </a:xfrm>
+          <a:prstGeom prst="rect">
+            <a:avLst/>
+          </a:prstGeom>
+        </p:spPr>
+        <p:style>
+          <a:lnRef idx="0">
+            <a:schemeClr val="accent4"/>
+          </a:lnRef>
+          <a:fillRef idx="3">
+            <a:schemeClr val="accent4"/>
+          </a:fillRef>
+          <a:effectRef idx="3">
+            <a:schemeClr val="accent4"/>
+          </a:effectRef>
+          <a:fontRef idx="minor">
+            <a:schemeClr val="lt1"/>
+          </a:fontRef>
+        </p:style>
+        <p:txBody>
+          <a:bodyPr rtlCol="0" anchor="ctr"/>
+          <a:lstStyle/>
+          <a:p>
+            <a:pPr algn="ctr"/>
+            <a:r>
+              <a:rPr lang="en-CA" dirty="0">
+                <a:solidFill>
+                  <a:schemeClr val="tx1"/>
+                </a:solidFill>
+              </a:rPr>
+              <a:t>Index </a:t>
+            </a:r>
+          </a:p>
+          <a:p>
+            <a:pPr algn="ctr"/>
+            <a:r>
+              <a:rPr lang="en-CA" dirty="0">
+                <a:solidFill>
+                  <a:schemeClr val="tx1"/>
+                </a:solidFill>
+              </a:rPr>
+              <a:t>Element</a:t>
+            </a:r>
+          </a:p>
+        </p:txBody>
+      </p:sp>
+    </p:spTree>
+    <p:extLst>
+      <p:ext uri="{BB962C8B-B14F-4D97-AF65-F5344CB8AC3E}">
+        <p14:creationId xmlns:p14="http://schemas.microsoft.com/office/powerpoint/2010/main" val="4259800843"/>
+      </p:ext>
+    </p:extLst>
+  </p:cSld>
+  <p:clrMapOvr>
+    <a:masterClrMapping/>
+  </p:clrMapOvr>
+</p:sld>
+</file>
+
+<file path=ppt/slides/slide5.xml><?xml version="1.0" encoding="utf-8"?>
+<p:sld xmlns:a="http://schemas.openxmlformats.org/drawingml/2006/main" xmlns:r="http://schemas.openxmlformats.org/officeDocument/2006/relationships" xmlns:p="http://schemas.openxmlformats.org/presentationml/2006/main">
+  <p:cSld>
+    <p:spTree>
+      <p:nvGrpSpPr>
+        <p:cNvPr id="1" name=""/>
+        <p:cNvGrpSpPr/>
+        <p:nvPr/>
+      </p:nvGrpSpPr>
+      <p:grpSpPr>
+        <a:xfrm>
+          <a:off x="0" y="0"/>
+          <a:ext cx="0" cy="0"/>
+          <a:chOff x="0" y="0"/>
+          <a:chExt cx="0" cy="0"/>
+        </a:xfrm>
+      </p:grpSpPr>
+      <p:sp>
+        <p:nvSpPr>
+          <p:cNvPr id="5" name="Rectangle: Rounded Corners 4">
+            <a:extLst>
+              <a:ext uri="{FF2B5EF4-FFF2-40B4-BE49-F238E27FC236}">
+                <a16:creationId xmlns:a16="http://schemas.microsoft.com/office/drawing/2014/main" id="{855FD758-8CA8-97F0-86A6-673795C8D55E}"/>
+              </a:ext>
+            </a:extLst>
+          </p:cNvPr>
+          <p:cNvSpPr/>
+          <p:nvPr/>
+        </p:nvSpPr>
+        <p:spPr>
+          <a:xfrm>
+            <a:off x="1292596" y="88490"/>
+            <a:ext cx="3476050" cy="6459794"/>
+          </a:xfrm>
+          <a:prstGeom prst="roundRect">
+            <a:avLst/>
+          </a:prstGeom>
+        </p:spPr>
+        <p:style>
+          <a:lnRef idx="2">
+            <a:schemeClr val="accent1">
+              <a:shade val="15000"/>
+            </a:schemeClr>
+          </a:lnRef>
+          <a:fillRef idx="1">
+            <a:schemeClr val="accent1"/>
+          </a:fillRef>
+          <a:effectRef idx="0">
+            <a:schemeClr val="accent1"/>
+          </a:effectRef>
+          <a:fontRef idx="minor">
+            <a:schemeClr val="lt1"/>
+          </a:fontRef>
+        </p:style>
+        <p:txBody>
+          <a:bodyPr rtlCol="0" anchor="ctr"/>
+          <a:lstStyle/>
+          <a:p>
+            <a:pPr algn="ctr"/>
+            <a:r>
+              <a:rPr lang="en-CA" dirty="0"/>
+              <a:t>CPU (C++)</a:t>
+            </a:r>
+          </a:p>
+          <a:p>
+            <a:pPr algn="ctr"/>
+            <a:endParaRPr lang="en-CA" dirty="0"/>
+          </a:p>
+          <a:p>
+            <a:pPr algn="ctr"/>
+            <a:endParaRPr lang="en-CA" dirty="0"/>
+          </a:p>
+          <a:p>
+            <a:pPr algn="ctr"/>
+            <a:endParaRPr lang="en-CA" dirty="0"/>
+          </a:p>
+          <a:p>
+            <a:pPr algn="ctr"/>
+            <a:endParaRPr lang="en-CA" dirty="0"/>
+          </a:p>
+          <a:p>
+            <a:pPr algn="ctr"/>
+            <a:endParaRPr lang="en-CA" dirty="0"/>
+          </a:p>
+          <a:p>
+            <a:pPr algn="ctr"/>
+            <a:endParaRPr lang="en-CA" dirty="0"/>
+          </a:p>
+          <a:p>
+            <a:pPr algn="ctr"/>
+            <a:endParaRPr lang="en-CA" dirty="0"/>
+          </a:p>
+          <a:p>
+            <a:pPr algn="ctr"/>
+            <a:endParaRPr lang="en-CA" dirty="0"/>
+          </a:p>
+          <a:p>
+            <a:pPr algn="ctr"/>
+            <a:endParaRPr lang="en-CA" dirty="0"/>
+          </a:p>
+          <a:p>
+            <a:pPr algn="ctr"/>
+            <a:endParaRPr lang="en-CA" dirty="0"/>
+          </a:p>
+          <a:p>
+            <a:pPr algn="ctr"/>
+            <a:endParaRPr lang="en-CA" dirty="0"/>
+          </a:p>
+          <a:p>
+            <a:pPr algn="ctr"/>
+            <a:endParaRPr lang="en-CA" dirty="0"/>
+          </a:p>
+          <a:p>
+            <a:pPr algn="ctr"/>
+            <a:endParaRPr lang="en-CA" dirty="0"/>
+          </a:p>
+          <a:p>
+            <a:pPr algn="ctr"/>
+            <a:endParaRPr lang="en-CA" dirty="0"/>
+          </a:p>
+          <a:p>
+            <a:pPr algn="ctr"/>
+            <a:endParaRPr lang="en-CA" dirty="0"/>
+          </a:p>
+          <a:p>
+            <a:pPr algn="ctr"/>
+            <a:endParaRPr lang="en-CA" dirty="0"/>
+          </a:p>
+          <a:p>
+            <a:pPr algn="ctr"/>
+            <a:r>
+              <a:rPr lang="en-CA" dirty="0"/>
+              <a:t> </a:t>
+            </a:r>
+          </a:p>
+        </p:txBody>
+      </p:sp>
+      <p:sp>
+        <p:nvSpPr>
+          <p:cNvPr id="6" name="Rectangle: Rounded Corners 5">
+            <a:extLst>
+              <a:ext uri="{FF2B5EF4-FFF2-40B4-BE49-F238E27FC236}">
+                <a16:creationId xmlns:a16="http://schemas.microsoft.com/office/drawing/2014/main" id="{A7AB6A8E-617B-EFE7-82EB-41E6C14BB692}"/>
+              </a:ext>
+            </a:extLst>
+          </p:cNvPr>
+          <p:cNvSpPr/>
+          <p:nvPr/>
+        </p:nvSpPr>
+        <p:spPr>
+          <a:xfrm>
+            <a:off x="5899356" y="68824"/>
+            <a:ext cx="5309418" cy="6459794"/>
+          </a:xfrm>
+          <a:prstGeom prst="roundRect">
+            <a:avLst/>
+          </a:prstGeom>
+        </p:spPr>
+        <p:style>
+          <a:lnRef idx="2">
+            <a:schemeClr val="accent1">
+              <a:shade val="15000"/>
+            </a:schemeClr>
+          </a:lnRef>
+          <a:fillRef idx="1">
+            <a:schemeClr val="accent1"/>
+          </a:fillRef>
+          <a:effectRef idx="0">
+            <a:schemeClr val="accent1"/>
+          </a:effectRef>
+          <a:fontRef idx="minor">
+            <a:schemeClr val="lt1"/>
+          </a:fontRef>
+        </p:style>
+        <p:txBody>
+          <a:bodyPr rtlCol="0" anchor="ctr"/>
+          <a:lstStyle/>
+          <a:p>
+            <a:pPr algn="ctr"/>
+            <a:r>
+              <a:rPr lang="en-CA" dirty="0"/>
+              <a:t>GPU</a:t>
+            </a:r>
+          </a:p>
+          <a:p>
+            <a:pPr algn="ctr"/>
+            <a:endParaRPr lang="en-CA" dirty="0"/>
+          </a:p>
+          <a:p>
+            <a:pPr algn="ctr"/>
+            <a:endParaRPr lang="en-CA" dirty="0"/>
+          </a:p>
+          <a:p>
+            <a:pPr algn="ctr"/>
+            <a:endParaRPr lang="en-CA" dirty="0"/>
+          </a:p>
+          <a:p>
+            <a:pPr algn="ctr"/>
+            <a:endParaRPr lang="en-CA" dirty="0"/>
+          </a:p>
+          <a:p>
+            <a:pPr algn="ctr"/>
+            <a:endParaRPr lang="en-CA" dirty="0"/>
+          </a:p>
+          <a:p>
+            <a:pPr algn="ctr"/>
+            <a:endParaRPr lang="en-CA" dirty="0"/>
+          </a:p>
+          <a:p>
+            <a:pPr algn="ctr"/>
+            <a:endParaRPr lang="en-CA" dirty="0"/>
+          </a:p>
+          <a:p>
+            <a:pPr algn="ctr"/>
+            <a:endParaRPr lang="en-CA" dirty="0"/>
+          </a:p>
+          <a:p>
+            <a:pPr algn="ctr"/>
+            <a:endParaRPr lang="en-CA" dirty="0"/>
+          </a:p>
+          <a:p>
+            <a:pPr algn="ctr"/>
+            <a:endParaRPr lang="en-CA" dirty="0"/>
+          </a:p>
+          <a:p>
+            <a:pPr algn="ctr"/>
+            <a:endParaRPr lang="en-CA" dirty="0"/>
+          </a:p>
+          <a:p>
+            <a:pPr algn="ctr"/>
+            <a:endParaRPr lang="en-CA" dirty="0"/>
+          </a:p>
+          <a:p>
+            <a:pPr algn="ctr"/>
+            <a:endParaRPr lang="en-CA" dirty="0"/>
+          </a:p>
+          <a:p>
+            <a:pPr algn="ctr"/>
+            <a:endParaRPr lang="en-CA" dirty="0"/>
+          </a:p>
+          <a:p>
+            <a:pPr algn="ctr"/>
+            <a:endParaRPr lang="en-CA" dirty="0"/>
+          </a:p>
+          <a:p>
+            <a:pPr algn="ctr"/>
+            <a:endParaRPr lang="en-CA" dirty="0"/>
+          </a:p>
+          <a:p>
+            <a:pPr algn="ctr"/>
+            <a:endParaRPr lang="en-CA" dirty="0"/>
+          </a:p>
+        </p:txBody>
+      </p:sp>
+      <p:sp>
+        <p:nvSpPr>
+          <p:cNvPr id="8" name="Arrow: Right 7">
+            <a:extLst>
+              <a:ext uri="{FF2B5EF4-FFF2-40B4-BE49-F238E27FC236}">
+                <a16:creationId xmlns:a16="http://schemas.microsoft.com/office/drawing/2014/main" id="{9E9D5935-7A52-C77B-8374-E864BCEE7462}"/>
+              </a:ext>
+            </a:extLst>
+          </p:cNvPr>
+          <p:cNvSpPr/>
+          <p:nvPr/>
+        </p:nvSpPr>
+        <p:spPr>
+          <a:xfrm>
+            <a:off x="4486589" y="1312606"/>
+            <a:ext cx="1944326" cy="1219200"/>
+          </a:xfrm>
+          <a:prstGeom prst="rightArrow">
+            <a:avLst/>
+          </a:prstGeom>
+        </p:spPr>
+        <p:style>
+          <a:lnRef idx="1">
+            <a:schemeClr val="accent2"/>
+          </a:lnRef>
+          <a:fillRef idx="3">
+            <a:schemeClr val="accent2"/>
+          </a:fillRef>
+          <a:effectRef idx="2">
+            <a:schemeClr val="accent2"/>
+          </a:effectRef>
+          <a:fontRef idx="minor">
+            <a:schemeClr val="lt1"/>
+          </a:fontRef>
+        </p:style>
+        <p:txBody>
+          <a:bodyPr rtlCol="0" anchor="ctr"/>
+          <a:lstStyle/>
+          <a:p>
+            <a:pPr algn="ctr"/>
+            <a:endParaRPr lang="en-CA"/>
+          </a:p>
+        </p:txBody>
+      </p:sp>
+      <p:sp>
+        <p:nvSpPr>
+          <p:cNvPr id="11" name="Rectangle: Rounded Corners 10">
+            <a:extLst>
+              <a:ext uri="{FF2B5EF4-FFF2-40B4-BE49-F238E27FC236}">
+                <a16:creationId xmlns:a16="http://schemas.microsoft.com/office/drawing/2014/main" id="{DD8208FC-83C2-3DB4-987C-E51904197546}"/>
+              </a:ext>
+            </a:extLst>
+          </p:cNvPr>
+          <p:cNvSpPr/>
+          <p:nvPr/>
+        </p:nvSpPr>
+        <p:spPr>
+          <a:xfrm>
+            <a:off x="8554065" y="1622323"/>
+            <a:ext cx="2792361" cy="2969343"/>
+          </a:xfrm>
+          <a:prstGeom prst="roundRect">
+            <a:avLst/>
+          </a:prstGeom>
+        </p:spPr>
+        <p:style>
+          <a:lnRef idx="2">
+            <a:schemeClr val="accent1">
+              <a:shade val="15000"/>
+            </a:schemeClr>
+          </a:lnRef>
+          <a:fillRef idx="1">
+            <a:schemeClr val="accent1"/>
+          </a:fillRef>
+          <a:effectRef idx="0">
+            <a:schemeClr val="accent1"/>
+          </a:effectRef>
+          <a:fontRef idx="minor">
+            <a:schemeClr val="lt1"/>
+          </a:fontRef>
+        </p:style>
+        <p:txBody>
+          <a:bodyPr rtlCol="0" anchor="ctr"/>
+          <a:lstStyle/>
+          <a:p>
+            <a:pPr algn="ctr"/>
+            <a:r>
+              <a:rPr lang="en-CA" dirty="0"/>
+              <a:t>Shader “Program”</a:t>
+            </a:r>
+          </a:p>
+          <a:p>
+            <a:pPr algn="ctr"/>
+            <a:endParaRPr lang="en-CA" dirty="0"/>
+          </a:p>
+          <a:p>
+            <a:pPr algn="ctr"/>
+            <a:endParaRPr lang="en-CA" dirty="0"/>
+          </a:p>
+          <a:p>
+            <a:pPr algn="ctr"/>
+            <a:endParaRPr lang="en-CA" dirty="0"/>
+          </a:p>
+          <a:p>
+            <a:pPr algn="ctr"/>
+            <a:endParaRPr lang="en-CA" dirty="0"/>
+          </a:p>
+          <a:p>
+            <a:pPr algn="ctr"/>
+            <a:endParaRPr lang="en-CA" dirty="0"/>
+          </a:p>
+          <a:p>
+            <a:pPr algn="ctr"/>
+            <a:endParaRPr lang="en-CA" dirty="0"/>
+          </a:p>
+          <a:p>
+            <a:pPr algn="ctr"/>
+            <a:endParaRPr lang="en-CA" dirty="0"/>
+          </a:p>
+          <a:p>
+            <a:pPr algn="ctr"/>
+            <a:endParaRPr lang="en-CA" dirty="0"/>
+          </a:p>
+          <a:p>
+            <a:pPr algn="ctr"/>
+            <a:endParaRPr lang="en-CA" dirty="0"/>
+          </a:p>
+        </p:txBody>
+      </p:sp>
+      <p:sp>
+        <p:nvSpPr>
+          <p:cNvPr id="9" name="Rectangle: Rounded Corners 8">
+            <a:extLst>
+              <a:ext uri="{FF2B5EF4-FFF2-40B4-BE49-F238E27FC236}">
+                <a16:creationId xmlns:a16="http://schemas.microsoft.com/office/drawing/2014/main" id="{C770166A-DA62-5E5D-EC57-615034048C5E}"/>
+              </a:ext>
+            </a:extLst>
+          </p:cNvPr>
+          <p:cNvSpPr/>
+          <p:nvPr/>
+        </p:nvSpPr>
+        <p:spPr>
+          <a:xfrm>
+            <a:off x="9026013" y="2271253"/>
+            <a:ext cx="1986116" cy="835742"/>
+          </a:xfrm>
+          <a:prstGeom prst="roundRect">
+            <a:avLst/>
+          </a:prstGeom>
+        </p:spPr>
+        <p:style>
+          <a:lnRef idx="3">
+            <a:schemeClr val="lt1"/>
+          </a:lnRef>
+          <a:fillRef idx="1">
+            <a:schemeClr val="accent4"/>
+          </a:fillRef>
+          <a:effectRef idx="1">
+            <a:schemeClr val="accent4"/>
+          </a:effectRef>
+          <a:fontRef idx="minor">
+            <a:schemeClr val="lt1"/>
+          </a:fontRef>
+        </p:style>
+        <p:txBody>
+          <a:bodyPr rtlCol="0" anchor="ctr"/>
+          <a:lstStyle/>
+          <a:p>
+            <a:pPr algn="ctr"/>
+            <a:r>
+              <a:rPr lang="en-CA" dirty="0">
+                <a:solidFill>
+                  <a:schemeClr val="tx1"/>
+                </a:solidFill>
+              </a:rPr>
+              <a:t>Vertex</a:t>
+            </a:r>
+          </a:p>
+        </p:txBody>
+      </p:sp>
+      <p:sp>
+        <p:nvSpPr>
+          <p:cNvPr id="10" name="Rectangle: Rounded Corners 9">
+            <a:extLst>
+              <a:ext uri="{FF2B5EF4-FFF2-40B4-BE49-F238E27FC236}">
+                <a16:creationId xmlns:a16="http://schemas.microsoft.com/office/drawing/2014/main" id="{F55A8CC1-47C2-1E03-2710-00949FBA61EF}"/>
+              </a:ext>
+            </a:extLst>
+          </p:cNvPr>
+          <p:cNvSpPr/>
+          <p:nvPr/>
+        </p:nvSpPr>
+        <p:spPr>
+          <a:xfrm>
+            <a:off x="9026013" y="3298724"/>
+            <a:ext cx="1986116" cy="835742"/>
+          </a:xfrm>
+          <a:prstGeom prst="roundRect">
+            <a:avLst/>
+          </a:prstGeom>
+        </p:spPr>
+        <p:style>
+          <a:lnRef idx="3">
+            <a:schemeClr val="lt1"/>
+          </a:lnRef>
+          <a:fillRef idx="1">
+            <a:schemeClr val="accent4"/>
+          </a:fillRef>
+          <a:effectRef idx="1">
+            <a:schemeClr val="accent4"/>
+          </a:effectRef>
+          <a:fontRef idx="minor">
+            <a:schemeClr val="lt1"/>
+          </a:fontRef>
+        </p:style>
+        <p:txBody>
+          <a:bodyPr rtlCol="0" anchor="ctr"/>
+          <a:lstStyle/>
+          <a:p>
+            <a:pPr algn="ctr"/>
+            <a:r>
+              <a:rPr lang="en-CA" dirty="0">
+                <a:solidFill>
+                  <a:schemeClr val="tx1"/>
+                </a:solidFill>
+              </a:rPr>
+              <a:t>Fragment</a:t>
+            </a:r>
+          </a:p>
+        </p:txBody>
+      </p:sp>
+      <p:sp>
+        <p:nvSpPr>
+          <p:cNvPr id="12" name="Arrow: Right 11">
+            <a:extLst>
+              <a:ext uri="{FF2B5EF4-FFF2-40B4-BE49-F238E27FC236}">
+                <a16:creationId xmlns:a16="http://schemas.microsoft.com/office/drawing/2014/main" id="{A94E4D52-A290-E5D3-0494-1F5571B038C3}"/>
+              </a:ext>
+            </a:extLst>
+          </p:cNvPr>
+          <p:cNvSpPr/>
+          <p:nvPr/>
+        </p:nvSpPr>
+        <p:spPr>
+          <a:xfrm>
+            <a:off x="11611896" y="2571136"/>
+            <a:ext cx="2261420" cy="1219200"/>
+          </a:xfrm>
+          <a:prstGeom prst="rightArrow">
+            <a:avLst/>
+          </a:prstGeom>
+        </p:spPr>
+        <p:style>
+          <a:lnRef idx="1">
+            <a:schemeClr val="accent2"/>
+          </a:lnRef>
+          <a:fillRef idx="3">
+            <a:schemeClr val="accent2"/>
+          </a:fillRef>
+          <a:effectRef idx="2">
+            <a:schemeClr val="accent2"/>
+          </a:effectRef>
+          <a:fontRef idx="minor">
+            <a:schemeClr val="lt1"/>
+          </a:fontRef>
+        </p:style>
+        <p:txBody>
+          <a:bodyPr rtlCol="0" anchor="ctr"/>
+          <a:lstStyle/>
+          <a:p>
+            <a:pPr algn="ctr"/>
+            <a:r>
+              <a:rPr lang="en-CA" dirty="0"/>
+              <a:t>To the screen (back buffer)</a:t>
+            </a:r>
+          </a:p>
+        </p:txBody>
+      </p:sp>
+      <p:sp>
+        <p:nvSpPr>
+          <p:cNvPr id="13" name="Arrow: Right 12">
+            <a:extLst>
+              <a:ext uri="{FF2B5EF4-FFF2-40B4-BE49-F238E27FC236}">
+                <a16:creationId xmlns:a16="http://schemas.microsoft.com/office/drawing/2014/main" id="{5F240329-D1AC-2AA6-9E5F-9F28FBD8DB21}"/>
+              </a:ext>
+            </a:extLst>
+          </p:cNvPr>
+          <p:cNvSpPr/>
+          <p:nvPr/>
+        </p:nvSpPr>
+        <p:spPr>
+          <a:xfrm>
+            <a:off x="7502016" y="1779639"/>
+            <a:ext cx="1565787" cy="1219200"/>
+          </a:xfrm>
+          <a:prstGeom prst="rightArrow">
+            <a:avLst/>
+          </a:prstGeom>
+        </p:spPr>
+        <p:style>
+          <a:lnRef idx="1">
+            <a:schemeClr val="accent2"/>
+          </a:lnRef>
+          <a:fillRef idx="3">
+            <a:schemeClr val="accent2"/>
+          </a:fillRef>
+          <a:effectRef idx="2">
+            <a:schemeClr val="accent2"/>
+          </a:effectRef>
+          <a:fontRef idx="minor">
+            <a:schemeClr val="lt1"/>
+          </a:fontRef>
+        </p:style>
+        <p:txBody>
+          <a:bodyPr rtlCol="0" anchor="ctr"/>
+          <a:lstStyle/>
+          <a:p>
+            <a:pPr algn="ctr"/>
+            <a:r>
+              <a:rPr lang="en-CA" dirty="0"/>
+              <a:t>     VL 	</a:t>
+            </a:r>
+          </a:p>
+        </p:txBody>
+      </p:sp>
+      <p:sp>
+        <p:nvSpPr>
+          <p:cNvPr id="14" name="Rectangle 13">
+            <a:extLst>
+              <a:ext uri="{FF2B5EF4-FFF2-40B4-BE49-F238E27FC236}">
+                <a16:creationId xmlns:a16="http://schemas.microsoft.com/office/drawing/2014/main" id="{FEF9F6F0-10D3-CC44-912C-80D329FB5F3C}"/>
+              </a:ext>
+            </a:extLst>
+          </p:cNvPr>
+          <p:cNvSpPr/>
+          <p:nvPr/>
+        </p:nvSpPr>
+        <p:spPr>
+          <a:xfrm>
+            <a:off x="-1518476" y="1199536"/>
+            <a:ext cx="1779638" cy="3962400"/>
+          </a:xfrm>
+          <a:prstGeom prst="rect">
+            <a:avLst/>
+          </a:prstGeom>
+        </p:spPr>
+        <p:style>
+          <a:lnRef idx="3">
+            <a:schemeClr val="lt1"/>
+          </a:lnRef>
+          <a:fillRef idx="1">
+            <a:schemeClr val="accent6"/>
+          </a:fillRef>
+          <a:effectRef idx="1">
+            <a:schemeClr val="accent6"/>
+          </a:effectRef>
+          <a:fontRef idx="minor">
+            <a:schemeClr val="lt1"/>
+          </a:fontRef>
+        </p:style>
+        <p:txBody>
+          <a:bodyPr rtlCol="0" anchor="ctr"/>
+          <a:lstStyle/>
+          <a:p>
+            <a:pPr algn="ctr"/>
+            <a:r>
+              <a:rPr lang="en-CA" dirty="0"/>
+              <a:t>File</a:t>
+            </a:r>
+          </a:p>
+        </p:txBody>
+      </p:sp>
+      <p:sp>
+        <p:nvSpPr>
+          <p:cNvPr id="15" name="Arrow: Right 14">
+            <a:extLst>
+              <a:ext uri="{FF2B5EF4-FFF2-40B4-BE49-F238E27FC236}">
+                <a16:creationId xmlns:a16="http://schemas.microsoft.com/office/drawing/2014/main" id="{54854930-83AB-D2BB-035E-DDEA1FA8DE37}"/>
+              </a:ext>
+            </a:extLst>
+          </p:cNvPr>
+          <p:cNvSpPr/>
+          <p:nvPr/>
+        </p:nvSpPr>
+        <p:spPr>
+          <a:xfrm>
+            <a:off x="-69458" y="2571136"/>
+            <a:ext cx="1499418" cy="1219200"/>
+          </a:xfrm>
+          <a:prstGeom prst="rightArrow">
+            <a:avLst/>
+          </a:prstGeom>
+        </p:spPr>
+        <p:style>
+          <a:lnRef idx="1">
+            <a:schemeClr val="accent2"/>
+          </a:lnRef>
+          <a:fillRef idx="3">
+            <a:schemeClr val="accent2"/>
+          </a:fillRef>
+          <a:effectRef idx="2">
+            <a:schemeClr val="accent2"/>
+          </a:effectRef>
+          <a:fontRef idx="minor">
+            <a:schemeClr val="lt1"/>
+          </a:fontRef>
+        </p:style>
+        <p:txBody>
+          <a:bodyPr rtlCol="0" anchor="ctr"/>
+          <a:lstStyle/>
+          <a:p>
+            <a:pPr algn="ctr"/>
+            <a:endParaRPr lang="en-CA"/>
+          </a:p>
+        </p:txBody>
+      </p:sp>
+      <p:sp>
+        <p:nvSpPr>
+          <p:cNvPr id="2" name="Rectangle 1">
+            <a:extLst>
+              <a:ext uri="{FF2B5EF4-FFF2-40B4-BE49-F238E27FC236}">
+                <a16:creationId xmlns:a16="http://schemas.microsoft.com/office/drawing/2014/main" id="{8ACAC186-645C-EFF0-E5FA-8B3A73966620}"/>
+              </a:ext>
+            </a:extLst>
+          </p:cNvPr>
+          <p:cNvSpPr/>
+          <p:nvPr/>
+        </p:nvSpPr>
+        <p:spPr>
+          <a:xfrm>
+            <a:off x="6627560" y="329382"/>
+            <a:ext cx="929146" cy="2541637"/>
+          </a:xfrm>
+          <a:prstGeom prst="rect">
+            <a:avLst/>
+          </a:prstGeom>
+        </p:spPr>
+        <p:style>
+          <a:lnRef idx="3">
+            <a:schemeClr val="lt1"/>
+          </a:lnRef>
+          <a:fillRef idx="1">
+            <a:schemeClr val="accent6"/>
+          </a:fillRef>
+          <a:effectRef idx="1">
+            <a:schemeClr val="accent6"/>
+          </a:effectRef>
+          <a:fontRef idx="minor">
+            <a:schemeClr val="lt1"/>
+          </a:fontRef>
+        </p:style>
+        <p:txBody>
+          <a:bodyPr rtlCol="0" anchor="ctr"/>
+          <a:lstStyle/>
+          <a:p>
+            <a:pPr algn="ctr"/>
+            <a:r>
+              <a:rPr lang="en-CA" dirty="0"/>
+              <a:t>Vertex</a:t>
+            </a:r>
+          </a:p>
+          <a:p>
+            <a:pPr algn="ctr"/>
+            <a:r>
+              <a:rPr lang="en-CA" dirty="0"/>
+              <a:t>buffer</a:t>
+            </a:r>
+          </a:p>
+        </p:txBody>
+      </p:sp>
+      <p:sp>
+        <p:nvSpPr>
+          <p:cNvPr id="7" name="Rectangle 6">
+            <a:extLst>
+              <a:ext uri="{FF2B5EF4-FFF2-40B4-BE49-F238E27FC236}">
+                <a16:creationId xmlns:a16="http://schemas.microsoft.com/office/drawing/2014/main" id="{CD626B8F-0F7F-5215-2B75-F6535A80B784}"/>
+              </a:ext>
+            </a:extLst>
+          </p:cNvPr>
+          <p:cNvSpPr/>
+          <p:nvPr/>
+        </p:nvSpPr>
+        <p:spPr>
+          <a:xfrm>
+            <a:off x="1450575" y="1138084"/>
+            <a:ext cx="1031434" cy="2391697"/>
+          </a:xfrm>
+          <a:prstGeom prst="rect">
+            <a:avLst/>
+          </a:prstGeom>
+        </p:spPr>
+        <p:style>
+          <a:lnRef idx="0">
+            <a:schemeClr val="accent4"/>
+          </a:lnRef>
+          <a:fillRef idx="3">
+            <a:schemeClr val="accent4"/>
+          </a:fillRef>
+          <a:effectRef idx="3">
+            <a:schemeClr val="accent4"/>
+          </a:effectRef>
+          <a:fontRef idx="minor">
+            <a:schemeClr val="lt1"/>
+          </a:fontRef>
+        </p:style>
+        <p:txBody>
+          <a:bodyPr rtlCol="0" anchor="ctr"/>
+          <a:lstStyle/>
+          <a:p>
+            <a:pPr algn="ctr"/>
+            <a:r>
+              <a:rPr lang="en-CA" dirty="0">
+                <a:solidFill>
+                  <a:schemeClr val="tx1"/>
+                </a:solidFill>
+              </a:rPr>
+              <a:t>Format from file</a:t>
+            </a:r>
+          </a:p>
+        </p:txBody>
+      </p:sp>
+      <p:sp>
+        <p:nvSpPr>
+          <p:cNvPr id="19" name="Rectangle 18">
+            <a:extLst>
+              <a:ext uri="{FF2B5EF4-FFF2-40B4-BE49-F238E27FC236}">
+                <a16:creationId xmlns:a16="http://schemas.microsoft.com/office/drawing/2014/main" id="{C7983A4B-5E00-9FF3-8BE0-0E917D42BF22}"/>
+              </a:ext>
+            </a:extLst>
+          </p:cNvPr>
+          <p:cNvSpPr/>
+          <p:nvPr/>
+        </p:nvSpPr>
+        <p:spPr>
+          <a:xfrm>
+            <a:off x="6636825" y="3180736"/>
+            <a:ext cx="929146" cy="3151238"/>
+          </a:xfrm>
+          <a:prstGeom prst="rect">
+            <a:avLst/>
+          </a:prstGeom>
+        </p:spPr>
+        <p:style>
+          <a:lnRef idx="3">
+            <a:schemeClr val="lt1"/>
+          </a:lnRef>
+          <a:fillRef idx="1">
+            <a:schemeClr val="accent6"/>
+          </a:fillRef>
+          <a:effectRef idx="1">
+            <a:schemeClr val="accent6"/>
+          </a:effectRef>
+          <a:fontRef idx="minor">
+            <a:schemeClr val="lt1"/>
+          </a:fontRef>
+        </p:style>
+        <p:txBody>
+          <a:bodyPr rtlCol="0" anchor="ctr"/>
+          <a:lstStyle/>
+          <a:p>
+            <a:pPr algn="ctr"/>
+            <a:r>
+              <a:rPr lang="en-CA" dirty="0"/>
+              <a:t>Element</a:t>
+            </a:r>
+          </a:p>
+          <a:p>
+            <a:pPr algn="ctr"/>
+            <a:r>
+              <a:rPr lang="en-CA" dirty="0"/>
+              <a:t>buffer</a:t>
+            </a:r>
+          </a:p>
+        </p:txBody>
+      </p:sp>
+      <p:sp>
+        <p:nvSpPr>
+          <p:cNvPr id="21" name="Rectangle 20">
+            <a:extLst>
+              <a:ext uri="{FF2B5EF4-FFF2-40B4-BE49-F238E27FC236}">
+                <a16:creationId xmlns:a16="http://schemas.microsoft.com/office/drawing/2014/main" id="{CE9CFCD2-E4B0-E4EB-3684-069A93151F40}"/>
+              </a:ext>
+            </a:extLst>
+          </p:cNvPr>
+          <p:cNvSpPr/>
+          <p:nvPr/>
+        </p:nvSpPr>
+        <p:spPr>
+          <a:xfrm>
+            <a:off x="3405517" y="1106130"/>
+            <a:ext cx="1031434" cy="2391698"/>
+          </a:xfrm>
+          <a:prstGeom prst="rect">
+            <a:avLst/>
+          </a:prstGeom>
+        </p:spPr>
+        <p:style>
+          <a:lnRef idx="0">
+            <a:schemeClr val="accent4"/>
+          </a:lnRef>
+          <a:fillRef idx="3">
+            <a:schemeClr val="accent4"/>
+          </a:fillRef>
+          <a:effectRef idx="3">
+            <a:schemeClr val="accent4"/>
+          </a:effectRef>
+          <a:fontRef idx="minor">
+            <a:schemeClr val="lt1"/>
+          </a:fontRef>
+        </p:style>
+        <p:txBody>
+          <a:bodyPr rtlCol="0" anchor="ctr"/>
+          <a:lstStyle/>
+          <a:p>
+            <a:pPr algn="ctr"/>
+            <a:r>
+              <a:rPr lang="en-CA" dirty="0">
+                <a:solidFill>
+                  <a:schemeClr val="tx1"/>
+                </a:solidFill>
+              </a:rPr>
+              <a:t>Format Shader wants</a:t>
+            </a:r>
+          </a:p>
+        </p:txBody>
+      </p:sp>
+      <p:sp>
+        <p:nvSpPr>
+          <p:cNvPr id="22" name="Arrow: Right 21">
+            <a:extLst>
+              <a:ext uri="{FF2B5EF4-FFF2-40B4-BE49-F238E27FC236}">
+                <a16:creationId xmlns:a16="http://schemas.microsoft.com/office/drawing/2014/main" id="{E522362C-6638-6511-4DB0-D2A8BC431F1C}"/>
+              </a:ext>
+            </a:extLst>
+          </p:cNvPr>
+          <p:cNvSpPr/>
+          <p:nvPr/>
+        </p:nvSpPr>
+        <p:spPr>
+          <a:xfrm>
+            <a:off x="2482009" y="2708787"/>
+            <a:ext cx="1098936" cy="1219200"/>
+          </a:xfrm>
+          <a:prstGeom prst="rightArrow">
+            <a:avLst/>
+          </a:prstGeom>
+        </p:spPr>
+        <p:style>
+          <a:lnRef idx="1">
+            <a:schemeClr val="accent2"/>
+          </a:lnRef>
+          <a:fillRef idx="3">
+            <a:schemeClr val="accent2"/>
+          </a:fillRef>
+          <a:effectRef idx="2">
+            <a:schemeClr val="accent2"/>
+          </a:effectRef>
+          <a:fontRef idx="minor">
+            <a:schemeClr val="lt1"/>
+          </a:fontRef>
+        </p:style>
+        <p:txBody>
+          <a:bodyPr rtlCol="0" anchor="ctr"/>
+          <a:lstStyle/>
+          <a:p>
+            <a:pPr algn="ctr"/>
+            <a:endParaRPr lang="en-CA"/>
+          </a:p>
+        </p:txBody>
+      </p:sp>
+      <p:sp>
+        <p:nvSpPr>
+          <p:cNvPr id="23" name="Rectangle 22">
+            <a:extLst>
+              <a:ext uri="{FF2B5EF4-FFF2-40B4-BE49-F238E27FC236}">
+                <a16:creationId xmlns:a16="http://schemas.microsoft.com/office/drawing/2014/main" id="{53B79025-2823-FFE5-BEE3-D736D10F1D73}"/>
+              </a:ext>
+            </a:extLst>
+          </p:cNvPr>
+          <p:cNvSpPr/>
+          <p:nvPr/>
+        </p:nvSpPr>
+        <p:spPr>
+          <a:xfrm>
+            <a:off x="1467613" y="3891116"/>
+            <a:ext cx="1031434" cy="2391697"/>
+          </a:xfrm>
+          <a:prstGeom prst="rect">
+            <a:avLst/>
+          </a:prstGeom>
+        </p:spPr>
+        <p:style>
+          <a:lnRef idx="0">
+            <a:schemeClr val="accent4"/>
+          </a:lnRef>
+          <a:fillRef idx="3">
+            <a:schemeClr val="accent4"/>
+          </a:fillRef>
+          <a:effectRef idx="3">
+            <a:schemeClr val="accent4"/>
+          </a:effectRef>
+          <a:fontRef idx="minor">
+            <a:schemeClr val="lt1"/>
+          </a:fontRef>
+        </p:style>
+        <p:txBody>
+          <a:bodyPr rtlCol="0" anchor="ctr"/>
+          <a:lstStyle/>
+          <a:p>
+            <a:pPr algn="ctr"/>
+            <a:r>
+              <a:rPr lang="en-CA" dirty="0">
+                <a:solidFill>
+                  <a:schemeClr val="tx1"/>
+                </a:solidFill>
+              </a:rPr>
+              <a:t>Format from file</a:t>
+            </a:r>
+          </a:p>
+        </p:txBody>
+      </p:sp>
+      <p:sp>
+        <p:nvSpPr>
+          <p:cNvPr id="24" name="Rectangle 23">
+            <a:extLst>
+              <a:ext uri="{FF2B5EF4-FFF2-40B4-BE49-F238E27FC236}">
+                <a16:creationId xmlns:a16="http://schemas.microsoft.com/office/drawing/2014/main" id="{EAC6D7EF-A7E8-D59D-A0EC-B59E08A96ED8}"/>
+              </a:ext>
+            </a:extLst>
+          </p:cNvPr>
+          <p:cNvSpPr/>
+          <p:nvPr/>
+        </p:nvSpPr>
+        <p:spPr>
+          <a:xfrm>
+            <a:off x="3411387" y="3891115"/>
+            <a:ext cx="1031434" cy="2391698"/>
+          </a:xfrm>
+          <a:prstGeom prst="rect">
+            <a:avLst/>
+          </a:prstGeom>
+        </p:spPr>
+        <p:style>
+          <a:lnRef idx="0">
+            <a:schemeClr val="accent4"/>
+          </a:lnRef>
+          <a:fillRef idx="3">
+            <a:schemeClr val="accent4"/>
+          </a:fillRef>
+          <a:effectRef idx="3">
+            <a:schemeClr val="accent4"/>
+          </a:effectRef>
+          <a:fontRef idx="minor">
+            <a:schemeClr val="lt1"/>
+          </a:fontRef>
+        </p:style>
+        <p:txBody>
+          <a:bodyPr rtlCol="0" anchor="ctr"/>
+          <a:lstStyle/>
+          <a:p>
+            <a:pPr algn="ctr"/>
+            <a:r>
+              <a:rPr lang="en-CA" dirty="0">
+                <a:solidFill>
+                  <a:schemeClr val="tx1"/>
+                </a:solidFill>
+              </a:rPr>
+              <a:t>Format Shader wants</a:t>
+            </a:r>
+          </a:p>
+        </p:txBody>
+      </p:sp>
+    </p:spTree>
+    <p:extLst>
+      <p:ext uri="{BB962C8B-B14F-4D97-AF65-F5344CB8AC3E}">
+        <p14:creationId xmlns:p14="http://schemas.microsoft.com/office/powerpoint/2010/main" val="2647376582"/>
       </p:ext>
     </p:extLst>
   </p:cSld>

</xml_diff>